<commit_message>
Updating the slides for 2026 workshop.
</commit_message>
<xml_diff>
--- a/01_overview/Introduction_To_Debugging.pptx
+++ b/01_overview/Introduction_To_Debugging.pptx
@@ -12,21 +12,17 @@
     <p:sldId id="268" r:id="rId6"/>
     <p:sldId id="270" r:id="rId7"/>
     <p:sldId id="260" r:id="rId8"/>
-    <p:sldId id="261" r:id="rId9"/>
-    <p:sldId id="264" r:id="rId10"/>
-    <p:sldId id="275" r:id="rId11"/>
-    <p:sldId id="271" r:id="rId12"/>
-    <p:sldId id="280" r:id="rId13"/>
-    <p:sldId id="273" r:id="rId14"/>
-    <p:sldId id="272" r:id="rId15"/>
-    <p:sldId id="274" r:id="rId16"/>
-    <p:sldId id="262" r:id="rId17"/>
-    <p:sldId id="277" r:id="rId18"/>
-    <p:sldId id="278" r:id="rId19"/>
-    <p:sldId id="279" r:id="rId20"/>
-    <p:sldId id="263" r:id="rId21"/>
-    <p:sldId id="265" r:id="rId22"/>
-    <p:sldId id="266" r:id="rId23"/>
+    <p:sldId id="264" r:id="rId9"/>
+    <p:sldId id="275" r:id="rId10"/>
+    <p:sldId id="271" r:id="rId11"/>
+    <p:sldId id="280" r:id="rId12"/>
+    <p:sldId id="273" r:id="rId13"/>
+    <p:sldId id="272" r:id="rId14"/>
+    <p:sldId id="274" r:id="rId15"/>
+    <p:sldId id="279" r:id="rId16"/>
+    <p:sldId id="263" r:id="rId17"/>
+    <p:sldId id="265" r:id="rId18"/>
+    <p:sldId id="266" r:id="rId19"/>
   </p:sldIdLst>
   <p:sldSz cx="9144000" cy="6858000" type="screen4x3"/>
   <p:notesSz cx="6858000" cy="9144000"/>
@@ -369,7 +365,7 @@
           <a:p>
             <a:fld id="{672C8AC2-76E2-427A-8089-09F7E78DC497}" type="datetimeFigureOut">
               <a:rPr lang="en-US" smtClean="0"/>
-              <a:t>1/18/2024</a:t>
+              <a:t>1/15/2026</a:t>
             </a:fld>
             <a:endParaRPr lang="en-US"/>
           </a:p>
@@ -549,7 +545,7 @@
           <a:p>
             <a:fld id="{672C8AC2-76E2-427A-8089-09F7E78DC497}" type="datetimeFigureOut">
               <a:rPr lang="en-US" smtClean="0"/>
-              <a:t>1/18/2024</a:t>
+              <a:t>1/15/2026</a:t>
             </a:fld>
             <a:endParaRPr lang="en-US"/>
           </a:p>
@@ -719,7 +715,7 @@
           <a:p>
             <a:fld id="{672C8AC2-76E2-427A-8089-09F7E78DC497}" type="datetimeFigureOut">
               <a:rPr lang="en-US" smtClean="0"/>
-              <a:t>1/18/2024</a:t>
+              <a:t>1/15/2026</a:t>
             </a:fld>
             <a:endParaRPr lang="en-US"/>
           </a:p>
@@ -963,7 +959,7 @@
           <a:p>
             <a:fld id="{672C8AC2-76E2-427A-8089-09F7E78DC497}" type="datetimeFigureOut">
               <a:rPr lang="en-US" smtClean="0"/>
-              <a:t>1/18/2024</a:t>
+              <a:t>1/15/2026</a:t>
             </a:fld>
             <a:endParaRPr lang="en-US"/>
           </a:p>
@@ -1195,7 +1191,7 @@
           <a:p>
             <a:fld id="{672C8AC2-76E2-427A-8089-09F7E78DC497}" type="datetimeFigureOut">
               <a:rPr lang="en-US" smtClean="0"/>
-              <a:t>1/18/2024</a:t>
+              <a:t>1/15/2026</a:t>
             </a:fld>
             <a:endParaRPr lang="en-US"/>
           </a:p>
@@ -1562,7 +1558,7 @@
           <a:p>
             <a:fld id="{672C8AC2-76E2-427A-8089-09F7E78DC497}" type="datetimeFigureOut">
               <a:rPr lang="en-US" smtClean="0"/>
-              <a:t>1/18/2024</a:t>
+              <a:t>1/15/2026</a:t>
             </a:fld>
             <a:endParaRPr lang="en-US"/>
           </a:p>
@@ -1680,7 +1676,7 @@
           <a:p>
             <a:fld id="{672C8AC2-76E2-427A-8089-09F7E78DC497}" type="datetimeFigureOut">
               <a:rPr lang="en-US" smtClean="0"/>
-              <a:t>1/18/2024</a:t>
+              <a:t>1/15/2026</a:t>
             </a:fld>
             <a:endParaRPr lang="en-US"/>
           </a:p>
@@ -1775,7 +1771,7 @@
           <a:p>
             <a:fld id="{672C8AC2-76E2-427A-8089-09F7E78DC497}" type="datetimeFigureOut">
               <a:rPr lang="en-US" smtClean="0"/>
-              <a:t>1/18/2024</a:t>
+              <a:t>1/15/2026</a:t>
             </a:fld>
             <a:endParaRPr lang="en-US"/>
           </a:p>
@@ -2052,7 +2048,7 @@
           <a:p>
             <a:fld id="{672C8AC2-76E2-427A-8089-09F7E78DC497}" type="datetimeFigureOut">
               <a:rPr lang="en-US" smtClean="0"/>
-              <a:t>1/18/2024</a:t>
+              <a:t>1/15/2026</a:t>
             </a:fld>
             <a:endParaRPr lang="en-US"/>
           </a:p>
@@ -2309,7 +2305,7 @@
           <a:p>
             <a:fld id="{672C8AC2-76E2-427A-8089-09F7E78DC497}" type="datetimeFigureOut">
               <a:rPr lang="en-US" smtClean="0"/>
-              <a:t>1/18/2024</a:t>
+              <a:t>1/15/2026</a:t>
             </a:fld>
             <a:endParaRPr lang="en-US"/>
           </a:p>
@@ -2528,7 +2524,7 @@
           <a:p>
             <a:fld id="{672C8AC2-76E2-427A-8089-09F7E78DC497}" type="datetimeFigureOut">
               <a:rPr lang="en-US" smtClean="0"/>
-              <a:t>1/18/2024</a:t>
+              <a:t>1/15/2026</a:t>
             </a:fld>
             <a:endParaRPr lang="en-US"/>
           </a:p>
@@ -2962,9 +2958,10 @@
           <a:lstStyle/>
           <a:p>
             <a:r>
-              <a:rPr lang="en-US" sz="5400" dirty="0"/>
-              <a:t>Debugging &amp; Profiling Code, in Python and R</a:t>
-            </a:r>
+              <a:rPr lang="en-US" b="1" dirty="0"/>
+              <a:t>Debugging and Profiling Code in Python</a:t>
+            </a:r>
+            <a:endParaRPr lang="en-US" sz="5400" dirty="0"/>
           </a:p>
         </p:txBody>
       </p:sp>
@@ -3018,20 +3015,8 @@
           </a:p>
           <a:p>
             <a:r>
-              <a:rPr lang="en-US" dirty="0" err="1"/>
-              <a:t>Wintersession</a:t>
-            </a:r>
-            <a:r>
-              <a:rPr lang="en-US" dirty="0"/>
-              <a:t> / </a:t>
-            </a:r>
-            <a:r>
-              <a:rPr lang="en-US" dirty="0" err="1"/>
-              <a:t>PICSciE</a:t>
-            </a:r>
-            <a:r>
-              <a:rPr lang="en-US" dirty="0"/>
-              <a:t> Training Workshops </a:t>
+              <a:rPr lang="en-US" dirty="0"/>
+              <a:t>WINTER 2026: Workshops and Mini-Courses </a:t>
             </a:r>
           </a:p>
           <a:p>
@@ -3056,149 +3041,6 @@
 </file>
 
 <file path=ppt/slides/slide10.xml><?xml version="1.0" encoding="utf-8"?>
-<p:sld xmlns:a="http://schemas.openxmlformats.org/drawingml/2006/main" xmlns:r="http://schemas.openxmlformats.org/officeDocument/2006/relationships" xmlns:p="http://schemas.openxmlformats.org/presentationml/2006/main">
-  <p:cSld>
-    <p:spTree>
-      <p:nvGrpSpPr>
-        <p:cNvPr id="1" name=""/>
-        <p:cNvGrpSpPr/>
-        <p:nvPr/>
-      </p:nvGrpSpPr>
-      <p:grpSpPr>
-        <a:xfrm>
-          <a:off x="0" y="0"/>
-          <a:ext cx="0" cy="0"/>
-          <a:chOff x="0" y="0"/>
-          <a:chExt cx="0" cy="0"/>
-        </a:xfrm>
-      </p:grpSpPr>
-      <p:sp>
-        <p:nvSpPr>
-          <p:cNvPr id="2" name="Title 1">
-            <a:extLst>
-              <a:ext uri="{FF2B5EF4-FFF2-40B4-BE49-F238E27FC236}">
-                <a16:creationId xmlns:a16="http://schemas.microsoft.com/office/drawing/2014/main" id="{5C298627-CFD5-A84F-8C30-6F138E6AD524}"/>
-              </a:ext>
-            </a:extLst>
-          </p:cNvPr>
-          <p:cNvSpPr>
-            <a:spLocks noGrp="1"/>
-          </p:cNvSpPr>
-          <p:nvPr>
-            <p:ph type="title"/>
-          </p:nvPr>
-        </p:nvSpPr>
-        <p:spPr/>
-        <p:txBody>
-          <a:bodyPr/>
-          <a:lstStyle/>
-          <a:p>
-            <a:r>
-              <a:rPr lang="en-US" dirty="0"/>
-              <a:t>Conditional Breakpoints</a:t>
-            </a:r>
-          </a:p>
-        </p:txBody>
-      </p:sp>
-      <p:sp>
-        <p:nvSpPr>
-          <p:cNvPr id="3" name="Content Placeholder 2">
-            <a:extLst>
-              <a:ext uri="{FF2B5EF4-FFF2-40B4-BE49-F238E27FC236}">
-                <a16:creationId xmlns:a16="http://schemas.microsoft.com/office/drawing/2014/main" id="{2BFD590D-9D84-284D-BE51-CE87B2A0EF92}"/>
-              </a:ext>
-            </a:extLst>
-          </p:cNvPr>
-          <p:cNvSpPr>
-            <a:spLocks noGrp="1"/>
-          </p:cNvSpPr>
-          <p:nvPr>
-            <p:ph idx="1"/>
-          </p:nvPr>
-        </p:nvSpPr>
-        <p:spPr/>
-        <p:txBody>
-          <a:bodyPr/>
-          <a:lstStyle/>
-          <a:p>
-            <a:pPr>
-              <a:lnSpc>
-                <a:spcPct val="200000"/>
-              </a:lnSpc>
-            </a:pPr>
-            <a:r>
-              <a:rPr lang="en-US" dirty="0"/>
-              <a:t>Sometimes breakpoints need to be conditional</a:t>
-            </a:r>
-          </a:p>
-          <a:p>
-            <a:pPr lvl="1">
-              <a:lnSpc>
-                <a:spcPct val="200000"/>
-              </a:lnSpc>
-            </a:pPr>
-            <a:r>
-              <a:rPr lang="en-US" dirty="0"/>
-              <a:t>Useful when breaking at a certain iteration</a:t>
-            </a:r>
-          </a:p>
-          <a:p>
-            <a:pPr lvl="1">
-              <a:lnSpc>
-                <a:spcPct val="200000"/>
-              </a:lnSpc>
-            </a:pPr>
-            <a:r>
-              <a:rPr lang="en-US" dirty="0"/>
-              <a:t>Breaking on a certain call of the function </a:t>
-            </a:r>
-          </a:p>
-          <a:p>
-            <a:pPr>
-              <a:lnSpc>
-                <a:spcPct val="200000"/>
-              </a:lnSpc>
-            </a:pPr>
-            <a:r>
-              <a:rPr lang="en-US" dirty="0"/>
-              <a:t>Run the “</a:t>
-            </a:r>
-            <a:r>
-              <a:rPr lang="en-US" dirty="0" err="1"/>
-              <a:t>triangle_area_many.py</a:t>
-            </a:r>
-            <a:r>
-              <a:rPr lang="en-US" dirty="0"/>
-              <a:t>” example</a:t>
-            </a:r>
-          </a:p>
-          <a:p>
-            <a:pPr lvl="1">
-              <a:lnSpc>
-                <a:spcPct val="200000"/>
-              </a:lnSpc>
-            </a:pPr>
-            <a:r>
-              <a:rPr lang="en-US" dirty="0"/>
-              <a:t>Figure out which of the 10000 triangles is failing!</a:t>
-            </a:r>
-          </a:p>
-        </p:txBody>
-      </p:sp>
-    </p:spTree>
-    <p:extLst>
-      <p:ext uri="{BB962C8B-B14F-4D97-AF65-F5344CB8AC3E}">
-        <p14:creationId xmlns:p14="http://schemas.microsoft.com/office/powerpoint/2010/main" val="3614469301"/>
-      </p:ext>
-    </p:extLst>
-  </p:cSld>
-  <p:clrMapOvr>
-    <a:masterClrMapping/>
-  </p:clrMapOvr>
-</p:sld>
-</file>
-
-<file path=ppt/slides/slide11.xml><?xml version="1.0" encoding="utf-8"?>
 <p:sld xmlns:a="http://schemas.openxmlformats.org/drawingml/2006/main" xmlns:r="http://schemas.openxmlformats.org/officeDocument/2006/relationships" xmlns:p="http://schemas.openxmlformats.org/presentationml/2006/main">
   <p:cSld>
     <p:spTree>
@@ -3424,6 +3266,184 @@
 </p:sld>
 </file>
 
+<file path=ppt/slides/slide11.xml><?xml version="1.0" encoding="utf-8"?>
+<p:sld xmlns:a="http://schemas.openxmlformats.org/drawingml/2006/main" xmlns:r="http://schemas.openxmlformats.org/officeDocument/2006/relationships" xmlns:p="http://schemas.openxmlformats.org/presentationml/2006/main">
+  <p:cSld>
+    <p:spTree>
+      <p:nvGrpSpPr>
+        <p:cNvPr id="1" name=""/>
+        <p:cNvGrpSpPr/>
+        <p:nvPr/>
+      </p:nvGrpSpPr>
+      <p:grpSpPr>
+        <a:xfrm>
+          <a:off x="0" y="0"/>
+          <a:ext cx="0" cy="0"/>
+          <a:chOff x="0" y="0"/>
+          <a:chExt cx="0" cy="0"/>
+        </a:xfrm>
+      </p:grpSpPr>
+      <p:sp>
+        <p:nvSpPr>
+          <p:cNvPr id="2" name="Title 1">
+            <a:extLst>
+              <a:ext uri="{FF2B5EF4-FFF2-40B4-BE49-F238E27FC236}">
+                <a16:creationId xmlns:a16="http://schemas.microsoft.com/office/drawing/2014/main" id="{C18F0CEB-5D93-7000-32C0-0B4D0EB05828}"/>
+              </a:ext>
+            </a:extLst>
+          </p:cNvPr>
+          <p:cNvSpPr>
+            <a:spLocks noGrp="1"/>
+          </p:cNvSpPr>
+          <p:nvPr>
+            <p:ph type="title"/>
+          </p:nvPr>
+        </p:nvSpPr>
+        <p:spPr/>
+        <p:txBody>
+          <a:bodyPr/>
+          <a:lstStyle/>
+          <a:p>
+            <a:r>
+              <a:rPr lang="en-US" dirty="0"/>
+              <a:t>Profiling with </a:t>
+            </a:r>
+            <a:r>
+              <a:rPr lang="en-US" dirty="0" err="1"/>
+              <a:t>line_profiler</a:t>
+            </a:r>
+            <a:endParaRPr lang="en-US" dirty="0"/>
+          </a:p>
+        </p:txBody>
+      </p:sp>
+      <p:sp>
+        <p:nvSpPr>
+          <p:cNvPr id="3" name="Content Placeholder 2">
+            <a:extLst>
+              <a:ext uri="{FF2B5EF4-FFF2-40B4-BE49-F238E27FC236}">
+                <a16:creationId xmlns:a16="http://schemas.microsoft.com/office/drawing/2014/main" id="{E981781A-10CC-6D01-A7A5-D66BF83A2ABF}"/>
+              </a:ext>
+            </a:extLst>
+          </p:cNvPr>
+          <p:cNvSpPr>
+            <a:spLocks noGrp="1"/>
+          </p:cNvSpPr>
+          <p:nvPr>
+            <p:ph idx="1"/>
+          </p:nvPr>
+        </p:nvSpPr>
+        <p:spPr/>
+        <p:txBody>
+          <a:bodyPr/>
+          <a:lstStyle/>
+          <a:p>
+            <a:r>
+              <a:rPr lang="en-US" dirty="0"/>
+              <a:t>Decorate the function to profile</a:t>
+            </a:r>
+          </a:p>
+          <a:p>
+            <a:pPr lvl="1"/>
+            <a:r>
+              <a:rPr lang="en-US" dirty="0"/>
+              <a:t>Annotate with @profile</a:t>
+            </a:r>
+          </a:p>
+          <a:p>
+            <a:pPr marL="457200" lvl="1" indent="0">
+              <a:buNone/>
+            </a:pPr>
+            <a:endParaRPr lang="en-US" dirty="0"/>
+          </a:p>
+          <a:p>
+            <a:r>
+              <a:rPr lang="en-US" dirty="0"/>
+              <a:t>Run the profiler</a:t>
+            </a:r>
+          </a:p>
+          <a:p>
+            <a:pPr lvl="1"/>
+            <a:r>
+              <a:rPr lang="en-US" dirty="0" err="1"/>
+              <a:t>kernprof</a:t>
+            </a:r>
+            <a:r>
+              <a:rPr lang="en-US" dirty="0"/>
+              <a:t> -l sort.py </a:t>
+            </a:r>
+            <a:r>
+              <a:rPr lang="en-US" dirty="0" err="1"/>
+              <a:t>snail_sort</a:t>
+            </a:r>
+            <a:endParaRPr lang="en-US" dirty="0"/>
+          </a:p>
+          <a:p>
+            <a:pPr marL="457200" lvl="1" indent="0">
+              <a:buNone/>
+            </a:pPr>
+            <a:endParaRPr lang="en-US" dirty="0"/>
+          </a:p>
+          <a:p>
+            <a:r>
+              <a:rPr lang="en-US" dirty="0"/>
+              <a:t>Inspect the profile</a:t>
+            </a:r>
+          </a:p>
+          <a:p>
+            <a:pPr lvl="1"/>
+            <a:r>
+              <a:rPr lang="en-US" dirty="0"/>
+              <a:t>python -m </a:t>
+            </a:r>
+            <a:r>
+              <a:rPr lang="en-US" dirty="0" err="1"/>
+              <a:t>line_profiler</a:t>
+            </a:r>
+            <a:r>
+              <a:rPr lang="en-US" dirty="0"/>
+              <a:t> -</a:t>
+            </a:r>
+            <a:r>
+              <a:rPr lang="en-US" dirty="0" err="1"/>
+              <a:t>rmt</a:t>
+            </a:r>
+            <a:r>
+              <a:rPr lang="en-US" dirty="0"/>
+              <a:t> </a:t>
+            </a:r>
+            <a:r>
+              <a:rPr lang="en-US" dirty="0" err="1"/>
+              <a:t>sort.py.lprof</a:t>
+            </a:r>
+            <a:endParaRPr lang="en-US" dirty="0"/>
+          </a:p>
+          <a:p>
+            <a:endParaRPr lang="en-US" dirty="0"/>
+          </a:p>
+          <a:p>
+            <a:endParaRPr lang="en-US" dirty="0"/>
+          </a:p>
+          <a:p>
+            <a:endParaRPr lang="en-US" dirty="0"/>
+          </a:p>
+          <a:p>
+            <a:endParaRPr lang="en-US" dirty="0"/>
+          </a:p>
+        </p:txBody>
+      </p:sp>
+    </p:spTree>
+    <p:extLst>
+      <p:ext uri="{BB962C8B-B14F-4D97-AF65-F5344CB8AC3E}">
+        <p14:creationId xmlns:p14="http://schemas.microsoft.com/office/powerpoint/2010/main" val="1275308604"/>
+      </p:ext>
+    </p:extLst>
+  </p:cSld>
+  <p:clrMapOvr>
+    <a:masterClrMapping/>
+  </p:clrMapOvr>
+</p:sld>
+</file>
+
 <file path=ppt/slides/slide12.xml><?xml version="1.0" encoding="utf-8"?>
 <p:sld xmlns:a="http://schemas.openxmlformats.org/drawingml/2006/main" xmlns:r="http://schemas.openxmlformats.org/officeDocument/2006/relationships" xmlns:p="http://schemas.openxmlformats.org/presentationml/2006/main">
   <p:cSld>
@@ -3443,184 +3463,6 @@
       </p:grpSpPr>
       <p:sp>
         <p:nvSpPr>
-          <p:cNvPr id="2" name="Title 1">
-            <a:extLst>
-              <a:ext uri="{FF2B5EF4-FFF2-40B4-BE49-F238E27FC236}">
-                <a16:creationId xmlns:a16="http://schemas.microsoft.com/office/drawing/2014/main" id="{C18F0CEB-5D93-7000-32C0-0B4D0EB05828}"/>
-              </a:ext>
-            </a:extLst>
-          </p:cNvPr>
-          <p:cNvSpPr>
-            <a:spLocks noGrp="1"/>
-          </p:cNvSpPr>
-          <p:nvPr>
-            <p:ph type="title"/>
-          </p:nvPr>
-        </p:nvSpPr>
-        <p:spPr/>
-        <p:txBody>
-          <a:bodyPr/>
-          <a:lstStyle/>
-          <a:p>
-            <a:r>
-              <a:rPr lang="en-US" dirty="0"/>
-              <a:t>Profiling with </a:t>
-            </a:r>
-            <a:r>
-              <a:rPr lang="en-US" dirty="0" err="1"/>
-              <a:t>line_profiler</a:t>
-            </a:r>
-            <a:endParaRPr lang="en-US" dirty="0"/>
-          </a:p>
-        </p:txBody>
-      </p:sp>
-      <p:sp>
-        <p:nvSpPr>
-          <p:cNvPr id="3" name="Content Placeholder 2">
-            <a:extLst>
-              <a:ext uri="{FF2B5EF4-FFF2-40B4-BE49-F238E27FC236}">
-                <a16:creationId xmlns:a16="http://schemas.microsoft.com/office/drawing/2014/main" id="{E981781A-10CC-6D01-A7A5-D66BF83A2ABF}"/>
-              </a:ext>
-            </a:extLst>
-          </p:cNvPr>
-          <p:cNvSpPr>
-            <a:spLocks noGrp="1"/>
-          </p:cNvSpPr>
-          <p:nvPr>
-            <p:ph idx="1"/>
-          </p:nvPr>
-        </p:nvSpPr>
-        <p:spPr/>
-        <p:txBody>
-          <a:bodyPr/>
-          <a:lstStyle/>
-          <a:p>
-            <a:r>
-              <a:rPr lang="en-US" dirty="0"/>
-              <a:t>Decorate the function to profile</a:t>
-            </a:r>
-          </a:p>
-          <a:p>
-            <a:pPr lvl="1"/>
-            <a:r>
-              <a:rPr lang="en-US" dirty="0"/>
-              <a:t>Annotate with @profile</a:t>
-            </a:r>
-          </a:p>
-          <a:p>
-            <a:pPr marL="457200" lvl="1" indent="0">
-              <a:buNone/>
-            </a:pPr>
-            <a:endParaRPr lang="en-US" dirty="0"/>
-          </a:p>
-          <a:p>
-            <a:r>
-              <a:rPr lang="en-US" dirty="0"/>
-              <a:t>Run the profiler</a:t>
-            </a:r>
-          </a:p>
-          <a:p>
-            <a:pPr lvl="1"/>
-            <a:r>
-              <a:rPr lang="en-US" dirty="0" err="1"/>
-              <a:t>kernprof</a:t>
-            </a:r>
-            <a:r>
-              <a:rPr lang="en-US" dirty="0"/>
-              <a:t> -l sort.py </a:t>
-            </a:r>
-            <a:r>
-              <a:rPr lang="en-US" dirty="0" err="1"/>
-              <a:t>snail_sort</a:t>
-            </a:r>
-            <a:endParaRPr lang="en-US" dirty="0"/>
-          </a:p>
-          <a:p>
-            <a:pPr marL="457200" lvl="1" indent="0">
-              <a:buNone/>
-            </a:pPr>
-            <a:endParaRPr lang="en-US" dirty="0"/>
-          </a:p>
-          <a:p>
-            <a:r>
-              <a:rPr lang="en-US" dirty="0"/>
-              <a:t>Inspect the profile</a:t>
-            </a:r>
-          </a:p>
-          <a:p>
-            <a:pPr lvl="1"/>
-            <a:r>
-              <a:rPr lang="en-US" dirty="0"/>
-              <a:t>python -m </a:t>
-            </a:r>
-            <a:r>
-              <a:rPr lang="en-US" dirty="0" err="1"/>
-              <a:t>line_profiler</a:t>
-            </a:r>
-            <a:r>
-              <a:rPr lang="en-US" dirty="0"/>
-              <a:t> -</a:t>
-            </a:r>
-            <a:r>
-              <a:rPr lang="en-US" dirty="0" err="1"/>
-              <a:t>rmt</a:t>
-            </a:r>
-            <a:r>
-              <a:rPr lang="en-US" dirty="0"/>
-              <a:t> </a:t>
-            </a:r>
-            <a:r>
-              <a:rPr lang="en-US" dirty="0" err="1"/>
-              <a:t>sort.py.lprof</a:t>
-            </a:r>
-            <a:endParaRPr lang="en-US" dirty="0"/>
-          </a:p>
-          <a:p>
-            <a:endParaRPr lang="en-US" dirty="0"/>
-          </a:p>
-          <a:p>
-            <a:endParaRPr lang="en-US" dirty="0"/>
-          </a:p>
-          <a:p>
-            <a:endParaRPr lang="en-US" dirty="0"/>
-          </a:p>
-          <a:p>
-            <a:endParaRPr lang="en-US" dirty="0"/>
-          </a:p>
-        </p:txBody>
-      </p:sp>
-    </p:spTree>
-    <p:extLst>
-      <p:ext uri="{BB962C8B-B14F-4D97-AF65-F5344CB8AC3E}">
-        <p14:creationId xmlns:p14="http://schemas.microsoft.com/office/powerpoint/2010/main" val="1275308604"/>
-      </p:ext>
-    </p:extLst>
-  </p:cSld>
-  <p:clrMapOvr>
-    <a:masterClrMapping/>
-  </p:clrMapOvr>
-</p:sld>
-</file>
-
-<file path=ppt/slides/slide13.xml><?xml version="1.0" encoding="utf-8"?>
-<p:sld xmlns:a="http://schemas.openxmlformats.org/drawingml/2006/main" xmlns:r="http://schemas.openxmlformats.org/officeDocument/2006/relationships" xmlns:p="http://schemas.openxmlformats.org/presentationml/2006/main">
-  <p:cSld>
-    <p:spTree>
-      <p:nvGrpSpPr>
-        <p:cNvPr id="1" name=""/>
-        <p:cNvGrpSpPr/>
-        <p:nvPr/>
-      </p:nvGrpSpPr>
-      <p:grpSpPr>
-        <a:xfrm>
-          <a:off x="0" y="0"/>
-          <a:ext cx="0" cy="0"/>
-          <a:chOff x="0" y="0"/>
-          <a:chExt cx="0" cy="0"/>
-        </a:xfrm>
-      </p:grpSpPr>
-      <p:sp>
-        <p:nvSpPr>
           <p:cNvPr id="4" name="Title 3">
             <a:extLst>
               <a:ext uri="{FF2B5EF4-FFF2-40B4-BE49-F238E27FC236}">
@@ -3688,7 +3530,7 @@
 </p:sld>
 </file>
 
-<file path=ppt/slides/slide14.xml><?xml version="1.0" encoding="utf-8"?>
+<file path=ppt/slides/slide13.xml><?xml version="1.0" encoding="utf-8"?>
 <p:sld xmlns:a="http://schemas.openxmlformats.org/drawingml/2006/main" xmlns:r="http://schemas.openxmlformats.org/officeDocument/2006/relationships" xmlns:p="http://schemas.openxmlformats.org/presentationml/2006/main">
   <p:cSld>
     <p:spTree>
@@ -3842,6 +3684,126 @@
 </p:sld>
 </file>
 
+<file path=ppt/slides/slide14.xml><?xml version="1.0" encoding="utf-8"?>
+<p:sld xmlns:a="http://schemas.openxmlformats.org/drawingml/2006/main" xmlns:r="http://schemas.openxmlformats.org/officeDocument/2006/relationships" xmlns:p="http://schemas.openxmlformats.org/presentationml/2006/main">
+  <p:cSld>
+    <p:spTree>
+      <p:nvGrpSpPr>
+        <p:cNvPr id="1" name=""/>
+        <p:cNvGrpSpPr/>
+        <p:nvPr/>
+      </p:nvGrpSpPr>
+      <p:grpSpPr>
+        <a:xfrm>
+          <a:off x="0" y="0"/>
+          <a:ext cx="0" cy="0"/>
+          <a:chOff x="0" y="0"/>
+          <a:chExt cx="0" cy="0"/>
+        </a:xfrm>
+      </p:grpSpPr>
+      <p:sp>
+        <p:nvSpPr>
+          <p:cNvPr id="2" name="Title 1">
+            <a:extLst>
+              <a:ext uri="{FF2B5EF4-FFF2-40B4-BE49-F238E27FC236}">
+                <a16:creationId xmlns:a16="http://schemas.microsoft.com/office/drawing/2014/main" id="{89D84DEE-AABE-1A40-BDA3-63074BA9A209}"/>
+              </a:ext>
+            </a:extLst>
+          </p:cNvPr>
+          <p:cNvSpPr>
+            <a:spLocks noGrp="1"/>
+          </p:cNvSpPr>
+          <p:nvPr>
+            <p:ph type="title"/>
+          </p:nvPr>
+        </p:nvSpPr>
+        <p:spPr/>
+        <p:txBody>
+          <a:bodyPr/>
+          <a:lstStyle/>
+          <a:p>
+            <a:r>
+              <a:rPr lang="en-US" dirty="0"/>
+              <a:t>Python Memory Profiling</a:t>
+            </a:r>
+          </a:p>
+        </p:txBody>
+      </p:sp>
+      <p:sp>
+        <p:nvSpPr>
+          <p:cNvPr id="3" name="Content Placeholder 2">
+            <a:extLst>
+              <a:ext uri="{FF2B5EF4-FFF2-40B4-BE49-F238E27FC236}">
+                <a16:creationId xmlns:a16="http://schemas.microsoft.com/office/drawing/2014/main" id="{3867BF66-576A-3E45-8486-D41374EF0156}"/>
+              </a:ext>
+            </a:extLst>
+          </p:cNvPr>
+          <p:cNvSpPr>
+            <a:spLocks noGrp="1"/>
+          </p:cNvSpPr>
+          <p:nvPr>
+            <p:ph idx="1"/>
+          </p:nvPr>
+        </p:nvSpPr>
+        <p:spPr/>
+        <p:txBody>
+          <a:bodyPr/>
+          <a:lstStyle/>
+          <a:p>
+            <a:r>
+              <a:rPr lang="en-US" dirty="0"/>
+              <a:t>Memory profiling show the instructions that significantly increase the memory usage</a:t>
+            </a:r>
+          </a:p>
+          <a:p>
+            <a:endParaRPr lang="en-US" dirty="0"/>
+          </a:p>
+          <a:p>
+            <a:r>
+              <a:rPr lang="en-US" dirty="0" err="1"/>
+              <a:t>memory_profiler</a:t>
+            </a:r>
+            <a:r>
+              <a:rPr lang="en-US" dirty="0"/>
+              <a:t> module allows users to decorate functions </a:t>
+            </a:r>
+          </a:p>
+          <a:p>
+            <a:endParaRPr lang="en-US" dirty="0"/>
+          </a:p>
+          <a:p>
+            <a:r>
+              <a:rPr lang="en-US" dirty="0"/>
+              <a:t>Shows total memory usage and lines that add to memory footprint</a:t>
+            </a:r>
+          </a:p>
+          <a:p>
+            <a:pPr lvl="1"/>
+            <a:r>
+              <a:rPr lang="en-US" dirty="0"/>
+              <a:t>python </a:t>
+            </a:r>
+            <a:r>
+              <a:rPr lang="en-US" dirty="0" err="1"/>
+              <a:t>mem_profile.py</a:t>
+            </a:r>
+            <a:endParaRPr lang="en-US" dirty="0"/>
+          </a:p>
+        </p:txBody>
+      </p:sp>
+    </p:spTree>
+    <p:extLst>
+      <p:ext uri="{BB962C8B-B14F-4D97-AF65-F5344CB8AC3E}">
+        <p14:creationId xmlns:p14="http://schemas.microsoft.com/office/powerpoint/2010/main" val="253782196"/>
+      </p:ext>
+    </p:extLst>
+  </p:cSld>
+  <p:clrMapOvr>
+    <a:masterClrMapping/>
+  </p:clrMapOvr>
+</p:sld>
+</file>
+
 <file path=ppt/slides/slide15.xml><?xml version="1.0" encoding="utf-8"?>
 <p:sld xmlns:a="http://schemas.openxmlformats.org/drawingml/2006/main" xmlns:r="http://schemas.openxmlformats.org/officeDocument/2006/relationships" xmlns:p="http://schemas.openxmlformats.org/presentationml/2006/main">
   <p:cSld>
@@ -3861,10 +3823,10 @@
       </p:grpSpPr>
       <p:sp>
         <p:nvSpPr>
-          <p:cNvPr id="2" name="Title 1">
+          <p:cNvPr id="5" name="Title 4">
             <a:extLst>
               <a:ext uri="{FF2B5EF4-FFF2-40B4-BE49-F238E27FC236}">
-                <a16:creationId xmlns:a16="http://schemas.microsoft.com/office/drawing/2014/main" id="{89D84DEE-AABE-1A40-BDA3-63074BA9A209}"/>
+                <a16:creationId xmlns:a16="http://schemas.microsoft.com/office/drawing/2014/main" id="{B36DB535-B2B8-DD49-916C-2B38FCB0595F}"/>
               </a:ext>
             </a:extLst>
           </p:cNvPr>
@@ -3872,87 +3834,25 @@
             <a:spLocks noGrp="1"/>
           </p:cNvSpPr>
           <p:nvPr>
-            <p:ph type="title"/>
-          </p:nvPr>
-        </p:nvSpPr>
-        <p:spPr/>
-        <p:txBody>
-          <a:bodyPr/>
-          <a:lstStyle/>
-          <a:p>
-            <a:r>
-              <a:rPr lang="en-US" dirty="0"/>
-              <a:t>Python Memory Profiling</a:t>
-            </a:r>
-          </a:p>
-        </p:txBody>
-      </p:sp>
-      <p:sp>
-        <p:nvSpPr>
-          <p:cNvPr id="3" name="Content Placeholder 2">
-            <a:extLst>
-              <a:ext uri="{FF2B5EF4-FFF2-40B4-BE49-F238E27FC236}">
-                <a16:creationId xmlns:a16="http://schemas.microsoft.com/office/drawing/2014/main" id="{3867BF66-576A-3E45-8486-D41374EF0156}"/>
-              </a:ext>
-            </a:extLst>
-          </p:cNvPr>
-          <p:cNvSpPr>
-            <a:spLocks noGrp="1"/>
-          </p:cNvSpPr>
-          <p:nvPr>
-            <p:ph idx="1"/>
-          </p:nvPr>
-        </p:nvSpPr>
-        <p:spPr/>
-        <p:txBody>
-          <a:bodyPr/>
-          <a:lstStyle/>
-          <a:p>
-            <a:r>
-              <a:rPr lang="en-US" dirty="0"/>
-              <a:t>Memory profiling show the instructions that significantly increase the memory usage</a:t>
-            </a:r>
-          </a:p>
-          <a:p>
-            <a:endParaRPr lang="en-US" dirty="0"/>
-          </a:p>
-          <a:p>
-            <a:r>
-              <a:rPr lang="en-US" dirty="0" err="1"/>
-              <a:t>memory_profiler</a:t>
-            </a:r>
-            <a:r>
-              <a:rPr lang="en-US" dirty="0"/>
-              <a:t> module allows users to decorate functions </a:t>
-            </a:r>
-          </a:p>
-          <a:p>
-            <a:endParaRPr lang="en-US" dirty="0"/>
-          </a:p>
-          <a:p>
-            <a:r>
-              <a:rPr lang="en-US" dirty="0"/>
-              <a:t>Shows total memory usage and lines that add to memory footprint</a:t>
-            </a:r>
-          </a:p>
-          <a:p>
-            <a:pPr lvl="1"/>
-            <a:r>
-              <a:rPr lang="en-US" dirty="0"/>
-              <a:t>python </a:t>
-            </a:r>
-            <a:r>
-              <a:rPr lang="en-US" dirty="0" err="1"/>
-              <a:t>mem_profile.py</a:t>
-            </a:r>
-            <a:endParaRPr lang="en-US" dirty="0"/>
+            <p:ph type="ctrTitle"/>
+          </p:nvPr>
+        </p:nvSpPr>
+        <p:spPr/>
+        <p:txBody>
+          <a:bodyPr/>
+          <a:lstStyle/>
+          <a:p>
+            <a:r>
+              <a:rPr lang="en-US" dirty="0"/>
+              <a:t>Have a great day!</a:t>
+            </a:r>
           </a:p>
         </p:txBody>
       </p:sp>
     </p:spTree>
     <p:extLst>
       <p:ext uri="{BB962C8B-B14F-4D97-AF65-F5344CB8AC3E}">
-        <p14:creationId xmlns:p14="http://schemas.microsoft.com/office/powerpoint/2010/main" val="253782196"/>
+        <p14:creationId xmlns:p14="http://schemas.microsoft.com/office/powerpoint/2010/main" val="3182097241"/>
       </p:ext>
     </p:extLst>
   </p:cSld>
@@ -3963,7 +3863,7 @@
 </file>
 
 <file path=ppt/slides/slide16.xml><?xml version="1.0" encoding="utf-8"?>
-<p:sld xmlns:a="http://schemas.openxmlformats.org/drawingml/2006/main" xmlns:r="http://schemas.openxmlformats.org/officeDocument/2006/relationships" xmlns:p="http://schemas.openxmlformats.org/presentationml/2006/main">
+<p:sld xmlns:a="http://schemas.openxmlformats.org/drawingml/2006/main" xmlns:r="http://schemas.openxmlformats.org/officeDocument/2006/relationships" xmlns:p="http://schemas.openxmlformats.org/presentationml/2006/main" show="0">
   <p:cSld>
     <p:spTree>
       <p:nvGrpSpPr>
@@ -3984,7 +3884,7 @@
           <p:cNvPr id="2" name="Title 1">
             <a:extLst>
               <a:ext uri="{FF2B5EF4-FFF2-40B4-BE49-F238E27FC236}">
-                <a16:creationId xmlns:a16="http://schemas.microsoft.com/office/drawing/2014/main" id="{5FD78A33-15E7-4009-995F-02F3FEF2E869}"/>
+                <a16:creationId xmlns:a16="http://schemas.microsoft.com/office/drawing/2014/main" id="{8B1EB113-6772-47FD-B086-3D873CE8642B}"/>
               </a:ext>
             </a:extLst>
           </p:cNvPr>
@@ -4002,15 +3902,7 @@
           <a:p>
             <a:r>
               <a:rPr lang="en-US" dirty="0"/>
-              <a:t>Exercise 3 : </a:t>
-            </a:r>
-            <a:r>
-              <a:rPr lang="en-US" dirty="0" err="1"/>
-              <a:t>Rstudio</a:t>
-            </a:r>
-            <a:r>
-              <a:rPr lang="en-US" dirty="0"/>
-              <a:t> Debugging</a:t>
+              <a:t>Handling C++</a:t>
             </a:r>
           </a:p>
         </p:txBody>
@@ -4020,7 +3912,7 @@
           <p:cNvPr id="3" name="Content Placeholder 2">
             <a:extLst>
               <a:ext uri="{FF2B5EF4-FFF2-40B4-BE49-F238E27FC236}">
-                <a16:creationId xmlns:a16="http://schemas.microsoft.com/office/drawing/2014/main" id="{8B7DDB34-81CC-4A34-9EC4-2E3400B990B8}"/>
+                <a16:creationId xmlns:a16="http://schemas.microsoft.com/office/drawing/2014/main" id="{39D54DE9-CBB0-4FEC-AB4C-2C31E7FAC625}"/>
               </a:ext>
             </a:extLst>
           </p:cNvPr>
@@ -4031,15 +3923,10 @@
             <p:ph idx="1"/>
           </p:nvPr>
         </p:nvSpPr>
-        <p:spPr>
-          <a:xfrm>
-            <a:off x="628650" y="1825625"/>
-            <a:ext cx="8022981" cy="4351338"/>
-          </a:xfrm>
-        </p:spPr>
+        <p:spPr/>
         <p:txBody>
           <a:bodyPr>
-            <a:normAutofit/>
+            <a:normAutofit fontScale="92500" lnSpcReduction="10000"/>
           </a:bodyPr>
           <a:lstStyle/>
           <a:p>
@@ -4050,7 +3937,29 @@
             </a:pPr>
             <a:r>
               <a:rPr lang="en-US" dirty="0"/>
-              <a:t>Download the file:</a:t>
+              <a:t>C++ is somewhat different because it is compiled </a:t>
+            </a:r>
+          </a:p>
+          <a:p>
+            <a:pPr>
+              <a:lnSpc>
+                <a:spcPct val="150000"/>
+              </a:lnSpc>
+            </a:pPr>
+            <a:r>
+              <a:rPr lang="en-US" dirty="0"/>
+              <a:t>Some errors are found much earlier </a:t>
+            </a:r>
+          </a:p>
+          <a:p>
+            <a:pPr>
+              <a:lnSpc>
+                <a:spcPct val="150000"/>
+              </a:lnSpc>
+            </a:pPr>
+            <a:r>
+              <a:rPr lang="en-US" dirty="0"/>
+              <a:t>The build process needs to be setup</a:t>
             </a:r>
           </a:p>
           <a:p>
@@ -4061,15 +3970,29 @@
             </a:pPr>
             <a:r>
               <a:rPr lang="en-US" dirty="0"/>
-              <a:t>Navigate to the </a:t>
-            </a:r>
-            <a:r>
-              <a:rPr lang="en-US" dirty="0" err="1"/>
-              <a:t>R_debug</a:t>
-            </a:r>
-            <a:r>
-              <a:rPr lang="en-US" dirty="0"/>
-              <a:t> folder</a:t>
+              <a:t>Compiler</a:t>
+            </a:r>
+          </a:p>
+          <a:p>
+            <a:pPr lvl="1">
+              <a:lnSpc>
+                <a:spcPct val="150000"/>
+              </a:lnSpc>
+            </a:pPr>
+            <a:r>
+              <a:rPr lang="en-US" dirty="0"/>
+              <a:t>Compiler options</a:t>
+            </a:r>
+          </a:p>
+          <a:p>
+            <a:pPr lvl="1">
+              <a:lnSpc>
+                <a:spcPct val="150000"/>
+              </a:lnSpc>
+            </a:pPr>
+            <a:r>
+              <a:rPr lang="en-US" dirty="0"/>
+              <a:t>Debug/Release builds</a:t>
             </a:r>
           </a:p>
           <a:p>
@@ -4080,62 +4003,15 @@
             </a:pPr>
             <a:r>
               <a:rPr lang="en-US" dirty="0"/>
-              <a:t>Click on the files to open </a:t>
-            </a:r>
-            <a:r>
-              <a:rPr lang="en-US" dirty="0" err="1"/>
-              <a:t>Rstudio</a:t>
-            </a:r>
-            <a:endParaRPr lang="en-US" dirty="0"/>
-          </a:p>
-          <a:p>
-            <a:pPr lvl="1">
-              <a:lnSpc>
-                <a:spcPct val="150000"/>
-              </a:lnSpc>
-            </a:pPr>
-            <a:r>
-              <a:rPr lang="en-US" dirty="0"/>
-              <a:t>Click on </a:t>
-            </a:r>
-            <a:r>
-              <a:rPr lang="en-US" b="1" dirty="0"/>
-              <a:t>Source</a:t>
-            </a:r>
-            <a:r>
-              <a:rPr lang="en-US" dirty="0"/>
-              <a:t> button to run the scripts</a:t>
-            </a:r>
-          </a:p>
-          <a:p>
-            <a:pPr>
-              <a:lnSpc>
-                <a:spcPct val="150000"/>
-              </a:lnSpc>
-            </a:pPr>
-            <a:r>
-              <a:rPr lang="en-US" dirty="0"/>
-              <a:t>Try to fix the infinite loop!</a:t>
-            </a:r>
-          </a:p>
-          <a:p>
-            <a:pPr lvl="1">
-              <a:lnSpc>
-                <a:spcPct val="150000"/>
-              </a:lnSpc>
-            </a:pPr>
-            <a:r>
-              <a:rPr lang="en-US" dirty="0" err="1"/>
-              <a:t>random_debug.R</a:t>
-            </a:r>
-            <a:endParaRPr lang="en-US" dirty="0"/>
+              <a:t>Errors messages can be less obvious </a:t>
+            </a:r>
           </a:p>
         </p:txBody>
       </p:sp>
     </p:spTree>
     <p:extLst>
       <p:ext uri="{BB962C8B-B14F-4D97-AF65-F5344CB8AC3E}">
-        <p14:creationId xmlns:p14="http://schemas.microsoft.com/office/powerpoint/2010/main" val="3476906450"/>
+        <p14:creationId xmlns:p14="http://schemas.microsoft.com/office/powerpoint/2010/main" val="237925523"/>
       </p:ext>
     </p:extLst>
   </p:cSld>
@@ -4146,7 +4022,7 @@
 </file>
 
 <file path=ppt/slides/slide17.xml><?xml version="1.0" encoding="utf-8"?>
-<p:sld xmlns:a="http://schemas.openxmlformats.org/drawingml/2006/main" xmlns:r="http://schemas.openxmlformats.org/officeDocument/2006/relationships" xmlns:p="http://schemas.openxmlformats.org/presentationml/2006/main">
+<p:sld xmlns:a="http://schemas.openxmlformats.org/drawingml/2006/main" xmlns:r="http://schemas.openxmlformats.org/officeDocument/2006/relationships" xmlns:p="http://schemas.openxmlformats.org/presentationml/2006/main" show="0">
   <p:cSld>
     <p:spTree>
       <p:nvGrpSpPr>
@@ -4167,7 +4043,7 @@
           <p:cNvPr id="2" name="Title 1">
             <a:extLst>
               <a:ext uri="{FF2B5EF4-FFF2-40B4-BE49-F238E27FC236}">
-                <a16:creationId xmlns:a16="http://schemas.microsoft.com/office/drawing/2014/main" id="{5FD78A33-15E7-4009-995F-02F3FEF2E869}"/>
+                <a16:creationId xmlns:a16="http://schemas.microsoft.com/office/drawing/2014/main" id="{E12BE167-F6C9-4FD8-AE90-A43FAAA42A07}"/>
               </a:ext>
             </a:extLst>
           </p:cNvPr>
@@ -4185,15 +4061,7 @@
           <a:p>
             <a:r>
               <a:rPr lang="en-US" dirty="0"/>
-              <a:t>Exercise 4 : </a:t>
-            </a:r>
-            <a:r>
-              <a:rPr lang="en-US" dirty="0" err="1"/>
-              <a:t>Rstudio</a:t>
-            </a:r>
-            <a:r>
-              <a:rPr lang="en-US" dirty="0"/>
-              <a:t> Profiling</a:t>
+              <a:t>Exercise 4 : C++ Setup</a:t>
             </a:r>
           </a:p>
         </p:txBody>
@@ -4203,7 +4071,7 @@
           <p:cNvPr id="3" name="Content Placeholder 2">
             <a:extLst>
               <a:ext uri="{FF2B5EF4-FFF2-40B4-BE49-F238E27FC236}">
-                <a16:creationId xmlns:a16="http://schemas.microsoft.com/office/drawing/2014/main" id="{8B7DDB34-81CC-4A34-9EC4-2E3400B990B8}"/>
+                <a16:creationId xmlns:a16="http://schemas.microsoft.com/office/drawing/2014/main" id="{6D93E6B7-65B4-4005-895B-4CD959210943}"/>
               </a:ext>
             </a:extLst>
           </p:cNvPr>
@@ -4216,8 +4084,8 @@
         </p:nvSpPr>
         <p:spPr>
           <a:xfrm>
-            <a:off x="628650" y="1825625"/>
-            <a:ext cx="8022981" cy="4351338"/>
+            <a:off x="211015" y="1825625"/>
+            <a:ext cx="8745415" cy="4351338"/>
           </a:xfrm>
         </p:spPr>
         <p:txBody>
@@ -4233,7 +4101,7 @@
             </a:pPr>
             <a:r>
               <a:rPr lang="en-US" dirty="0"/>
-              <a:t>Download the file:</a:t>
+              <a:t>Log onto Adroit </a:t>
             </a:r>
           </a:p>
           <a:p>
@@ -4243,16 +4111,18 @@
               </a:lnSpc>
             </a:pPr>
             <a:r>
-              <a:rPr lang="en-US" dirty="0"/>
-              <a:t>Navigate to the </a:t>
-            </a:r>
-            <a:r>
-              <a:rPr lang="en-US" dirty="0" err="1"/>
-              <a:t>R_profile</a:t>
-            </a:r>
-            <a:r>
-              <a:rPr lang="en-US" dirty="0"/>
-              <a:t> folder</a:t>
+              <a:rPr lang="en-US" dirty="0" err="1">
+                <a:latin typeface="Courier New" panose="02070309020205020404" pitchFamily="49" charset="0"/>
+                <a:cs typeface="Courier New" panose="02070309020205020404" pitchFamily="49" charset="0"/>
+              </a:rPr>
+              <a:t>ssh</a:t>
+            </a:r>
+            <a:r>
+              <a:rPr lang="en-US" dirty="0">
+                <a:latin typeface="Courier New" panose="02070309020205020404" pitchFamily="49" charset="0"/>
+                <a:cs typeface="Courier New" panose="02070309020205020404" pitchFamily="49" charset="0"/>
+              </a:rPr>
+              <a:t> -X adroit.princeton.edu</a:t>
             </a:r>
           </a:p>
           <a:p>
@@ -4263,13 +4133,8 @@
             </a:pPr>
             <a:r>
               <a:rPr lang="en-US" dirty="0"/>
-              <a:t>Click on the files to open </a:t>
-            </a:r>
-            <a:r>
-              <a:rPr lang="en-US" dirty="0" err="1"/>
-              <a:t>Rstudio</a:t>
-            </a:r>
-            <a:endParaRPr lang="en-US" dirty="0"/>
+              <a:t>Download the C++ code</a:t>
+            </a:r>
           </a:p>
           <a:p>
             <a:pPr lvl="1">
@@ -4278,43 +4143,104 @@
               </a:lnSpc>
             </a:pPr>
             <a:r>
-              <a:rPr lang="en-US" dirty="0"/>
-              <a:t>Click on </a:t>
-            </a:r>
-            <a:r>
-              <a:rPr lang="en-US" b="1" dirty="0"/>
-              <a:t>Source</a:t>
-            </a:r>
-            <a:r>
-              <a:rPr lang="en-US" dirty="0"/>
-              <a:t> button to run the scripts</a:t>
-            </a:r>
-          </a:p>
-          <a:p>
-            <a:pPr>
+              <a:rPr lang="pt-BR" sz="1800" dirty="0">
+                <a:latin typeface="Courier New" panose="02070309020205020404" pitchFamily="49" charset="0"/>
+                <a:cs typeface="Courier New" panose="02070309020205020404" pitchFamily="49" charset="0"/>
+              </a:rPr>
+              <a:t>curl -L -o cpp_debug.zip https://tinyurl.com/y3k73w6y</a:t>
+            </a:r>
+            <a:endParaRPr lang="en-US" sz="1800" dirty="0">
+              <a:latin typeface="Courier New" panose="02070309020205020404" pitchFamily="49" charset="0"/>
+              <a:cs typeface="Courier New" panose="02070309020205020404" pitchFamily="49" charset="0"/>
+            </a:endParaRPr>
+          </a:p>
+          <a:p>
+            <a:pPr lvl="1">
               <a:lnSpc>
                 <a:spcPct val="150000"/>
               </a:lnSpc>
             </a:pPr>
             <a:r>
-              <a:rPr lang="en-US" dirty="0"/>
-              <a:t>Let’s benchmark some sorting and </a:t>
-            </a:r>
-            <a:r>
-              <a:rPr lang="en-US" dirty="0" err="1"/>
-              <a:t>dataframe</a:t>
-            </a:r>
-            <a:r>
-              <a:rPr lang="en-US" dirty="0"/>
-              <a:t> operations</a:t>
-            </a:r>
+              <a:rPr lang="en-US" dirty="0">
+                <a:latin typeface="Courier New" panose="02070309020205020404" pitchFamily="49" charset="0"/>
+                <a:cs typeface="Courier New" panose="02070309020205020404" pitchFamily="49" charset="0"/>
+              </a:rPr>
+              <a:t>unzip </a:t>
+            </a:r>
+            <a:r>
+              <a:rPr lang="en-US" dirty="0" err="1">
+                <a:latin typeface="Courier New" panose="02070309020205020404" pitchFamily="49" charset="0"/>
+                <a:cs typeface="Courier New" panose="02070309020205020404" pitchFamily="49" charset="0"/>
+              </a:rPr>
+              <a:t>cpp</a:t>
+            </a:r>
+            <a:r>
+              <a:rPr lang="en-US" dirty="0">
+                <a:latin typeface="Courier New" panose="02070309020205020404" pitchFamily="49" charset="0"/>
+                <a:cs typeface="Courier New" panose="02070309020205020404" pitchFamily="49" charset="0"/>
+              </a:rPr>
+              <a:t>_</a:t>
+            </a:r>
+            <a:r>
+              <a:rPr lang="pt-BR" dirty="0">
+                <a:latin typeface="Courier New" panose="02070309020205020404" pitchFamily="49" charset="0"/>
+                <a:cs typeface="Courier New" panose="02070309020205020404" pitchFamily="49" charset="0"/>
+              </a:rPr>
+              <a:t>debug</a:t>
+            </a:r>
+            <a:r>
+              <a:rPr lang="en-US" dirty="0">
+                <a:latin typeface="Courier New" panose="02070309020205020404" pitchFamily="49" charset="0"/>
+                <a:cs typeface="Courier New" panose="02070309020205020404" pitchFamily="49" charset="0"/>
+              </a:rPr>
+              <a:t>.zip </a:t>
+            </a:r>
+          </a:p>
+          <a:p>
+            <a:pPr lvl="1">
+              <a:lnSpc>
+                <a:spcPct val="150000"/>
+              </a:lnSpc>
+            </a:pPr>
+            <a:r>
+              <a:rPr lang="en-US" dirty="0">
+                <a:latin typeface="Courier New" panose="02070309020205020404" pitchFamily="49" charset="0"/>
+                <a:cs typeface="Courier New" panose="02070309020205020404" pitchFamily="49" charset="0"/>
+              </a:rPr>
+              <a:t>cd </a:t>
+            </a:r>
+            <a:r>
+              <a:rPr lang="en-US" dirty="0" err="1">
+                <a:latin typeface="Courier New" panose="02070309020205020404" pitchFamily="49" charset="0"/>
+                <a:cs typeface="Courier New" panose="02070309020205020404" pitchFamily="49" charset="0"/>
+              </a:rPr>
+              <a:t>cpp</a:t>
+            </a:r>
+            <a:r>
+              <a:rPr lang="en-US" dirty="0">
+                <a:latin typeface="Courier New" panose="02070309020205020404" pitchFamily="49" charset="0"/>
+                <a:cs typeface="Courier New" panose="02070309020205020404" pitchFamily="49" charset="0"/>
+              </a:rPr>
+              <a:t>_</a:t>
+            </a:r>
+            <a:r>
+              <a:rPr lang="pt-BR" dirty="0">
+                <a:latin typeface="Courier New" panose="02070309020205020404" pitchFamily="49" charset="0"/>
+                <a:cs typeface="Courier New" panose="02070309020205020404" pitchFamily="49" charset="0"/>
+              </a:rPr>
+              <a:t>debug</a:t>
+            </a:r>
+            <a:endParaRPr lang="en-US" dirty="0">
+              <a:latin typeface="Courier New" panose="02070309020205020404" pitchFamily="49" charset="0"/>
+              <a:cs typeface="Courier New" panose="02070309020205020404" pitchFamily="49" charset="0"/>
+            </a:endParaRPr>
           </a:p>
         </p:txBody>
       </p:sp>
     </p:spTree>
     <p:extLst>
       <p:ext uri="{BB962C8B-B14F-4D97-AF65-F5344CB8AC3E}">
-        <p14:creationId xmlns:p14="http://schemas.microsoft.com/office/powerpoint/2010/main" val="4280221917"/>
+        <p14:creationId xmlns:p14="http://schemas.microsoft.com/office/powerpoint/2010/main" val="1010424374"/>
       </p:ext>
     </p:extLst>
   </p:cSld>
@@ -4325,7 +4251,7 @@
 </file>
 
 <file path=ppt/slides/slide18.xml><?xml version="1.0" encoding="utf-8"?>
-<p:sld xmlns:a="http://schemas.openxmlformats.org/drawingml/2006/main" xmlns:r="http://schemas.openxmlformats.org/officeDocument/2006/relationships" xmlns:p="http://schemas.openxmlformats.org/presentationml/2006/main">
+<p:sld xmlns:a="http://schemas.openxmlformats.org/drawingml/2006/main" xmlns:r="http://schemas.openxmlformats.org/officeDocument/2006/relationships" xmlns:p="http://schemas.openxmlformats.org/presentationml/2006/main" show="0">
   <p:cSld>
     <p:spTree>
       <p:nvGrpSpPr>
@@ -4346,7 +4272,7 @@
           <p:cNvPr id="2" name="Title 1">
             <a:extLst>
               <a:ext uri="{FF2B5EF4-FFF2-40B4-BE49-F238E27FC236}">
-                <a16:creationId xmlns:a16="http://schemas.microsoft.com/office/drawing/2014/main" id="{382E9FAD-7489-8246-AB49-9038C2DC9DB9}"/>
+                <a16:creationId xmlns:a16="http://schemas.microsoft.com/office/drawing/2014/main" id="{0A2DA531-92ED-4623-A4B8-90CE8F756834}"/>
               </a:ext>
             </a:extLst>
           </p:cNvPr>
@@ -4363,12 +4289,8 @@
           <a:lstStyle/>
           <a:p>
             <a:r>
-              <a:rPr lang="en-US" dirty="0" err="1"/>
-              <a:t>Profvis</a:t>
-            </a:r>
-            <a:r>
-              <a:rPr lang="en-US" dirty="0"/>
-              <a:t> Interactive Profiling </a:t>
+              <a:rPr lang="en-US" dirty="0"/>
+              <a:t>Exercise 4 : C++ Compile and Run </a:t>
             </a:r>
           </a:p>
         </p:txBody>
@@ -4378,7 +4300,7 @@
           <p:cNvPr id="3" name="Content Placeholder 2">
             <a:extLst>
               <a:ext uri="{FF2B5EF4-FFF2-40B4-BE49-F238E27FC236}">
-                <a16:creationId xmlns:a16="http://schemas.microsoft.com/office/drawing/2014/main" id="{BC1D1B41-1D1E-D140-8A40-75139359D97F}"/>
+                <a16:creationId xmlns:a16="http://schemas.microsoft.com/office/drawing/2014/main" id="{D1BF4B0F-0AD3-470A-B163-9EDCD95D5A97}"/>
               </a:ext>
             </a:extLst>
           </p:cNvPr>
@@ -4391,109 +4313,144 @@
         </p:nvSpPr>
         <p:spPr/>
         <p:txBody>
-          <a:bodyPr/>
-          <a:lstStyle/>
-          <a:p>
-            <a:r>
-              <a:rPr lang="en-US" dirty="0"/>
-              <a:t>Produces an interactive graph</a:t>
-            </a:r>
-          </a:p>
-          <a:p>
-            <a:endParaRPr lang="en-US" dirty="0"/>
-          </a:p>
-          <a:p>
-            <a:r>
-              <a:rPr lang="en-US" dirty="0"/>
-              <a:t>Statistical profiling using </a:t>
-            </a:r>
-            <a:r>
-              <a:rPr lang="en-US" dirty="0" err="1"/>
-              <a:t>Rprof</a:t>
-            </a:r>
-            <a:endParaRPr lang="en-US" dirty="0"/>
-          </a:p>
-          <a:p>
-            <a:pPr lvl="1"/>
-            <a:r>
-              <a:rPr lang="en-US" dirty="0"/>
-              <a:t>10ms intervals</a:t>
-            </a:r>
-          </a:p>
-          <a:p>
-            <a:pPr lvl="1"/>
-            <a:endParaRPr lang="en-US" dirty="0"/>
-          </a:p>
-          <a:p>
-            <a:r>
-              <a:rPr lang="en-US" dirty="0"/>
-              <a:t>The flame graph shows the lines of code where time was spent</a:t>
-            </a:r>
+          <a:bodyPr>
+            <a:normAutofit fontScale="92500" lnSpcReduction="20000"/>
+          </a:bodyPr>
+          <a:lstStyle/>
+          <a:p>
+            <a:pPr>
+              <a:lnSpc>
+                <a:spcPct val="150000"/>
+              </a:lnSpc>
+            </a:pPr>
+            <a:r>
+              <a:rPr lang="en-US" dirty="0"/>
+              <a:t>Compile the code</a:t>
+            </a:r>
+          </a:p>
+          <a:p>
+            <a:pPr lvl="1">
+              <a:lnSpc>
+                <a:spcPct val="150000"/>
+              </a:lnSpc>
+            </a:pPr>
+            <a:r>
+              <a:rPr lang="pt-BR" dirty="0">
+                <a:latin typeface="Courier New" panose="02070309020205020404" pitchFamily="49" charset="0"/>
+                <a:cs typeface="Courier New" panose="02070309020205020404" pitchFamily="49" charset="0"/>
+              </a:rPr>
+              <a:t>g++ -g -O0 -o serial_cpp serial.cpp</a:t>
+            </a:r>
+          </a:p>
+          <a:p>
+            <a:pPr>
+              <a:lnSpc>
+                <a:spcPct val="150000"/>
+              </a:lnSpc>
+            </a:pPr>
+            <a:r>
+              <a:rPr lang="pt-BR" dirty="0"/>
+              <a:t>Request a task node on Adroit</a:t>
+            </a:r>
+          </a:p>
+          <a:p>
+            <a:pPr lvl="1">
+              <a:lnSpc>
+                <a:spcPct val="150000"/>
+              </a:lnSpc>
+            </a:pPr>
+            <a:r>
+              <a:rPr lang="en-US" dirty="0" err="1">
+                <a:latin typeface="Courier New" panose="02070309020205020404" pitchFamily="49" charset="0"/>
+                <a:cs typeface="Courier New" panose="02070309020205020404" pitchFamily="49" charset="0"/>
+              </a:rPr>
+              <a:t>salloc</a:t>
+            </a:r>
+            <a:r>
+              <a:rPr lang="en-US" dirty="0">
+                <a:latin typeface="Courier New" panose="02070309020205020404" pitchFamily="49" charset="0"/>
+                <a:cs typeface="Courier New" panose="02070309020205020404" pitchFamily="49" charset="0"/>
+              </a:rPr>
+              <a:t> --nodes=1 --</a:t>
+            </a:r>
+            <a:r>
+              <a:rPr lang="en-US" dirty="0" err="1">
+                <a:latin typeface="Courier New" panose="02070309020205020404" pitchFamily="49" charset="0"/>
+                <a:cs typeface="Courier New" panose="02070309020205020404" pitchFamily="49" charset="0"/>
+              </a:rPr>
+              <a:t>ntasks</a:t>
+            </a:r>
+            <a:r>
+              <a:rPr lang="en-US" dirty="0">
+                <a:latin typeface="Courier New" panose="02070309020205020404" pitchFamily="49" charset="0"/>
+                <a:cs typeface="Courier New" panose="02070309020205020404" pitchFamily="49" charset="0"/>
+              </a:rPr>
+              <a:t>=1 --time=05:00 --x11</a:t>
+            </a:r>
+          </a:p>
+          <a:p>
+            <a:pPr>
+              <a:lnSpc>
+                <a:spcPct val="150000"/>
+              </a:lnSpc>
+            </a:pPr>
+            <a:r>
+              <a:rPr lang="en-US" dirty="0"/>
+              <a:t>Load the Arm DDT debugger </a:t>
+            </a:r>
+          </a:p>
+          <a:p>
+            <a:pPr lvl="1">
+              <a:lnSpc>
+                <a:spcPct val="150000"/>
+              </a:lnSpc>
+            </a:pPr>
+            <a:r>
+              <a:rPr lang="en-US" dirty="0">
+                <a:latin typeface="Courier New" panose="02070309020205020404" pitchFamily="49" charset="0"/>
+                <a:cs typeface="Courier New" panose="02070309020205020404" pitchFamily="49" charset="0"/>
+              </a:rPr>
+              <a:t>module load </a:t>
+            </a:r>
+            <a:r>
+              <a:rPr lang="en-US" dirty="0" err="1">
+                <a:latin typeface="Courier New" panose="02070309020205020404" pitchFamily="49" charset="0"/>
+                <a:cs typeface="Courier New" panose="02070309020205020404" pitchFamily="49" charset="0"/>
+              </a:rPr>
+              <a:t>ddt</a:t>
+            </a:r>
+            <a:r>
+              <a:rPr lang="en-US" dirty="0">
+                <a:latin typeface="Courier New" panose="02070309020205020404" pitchFamily="49" charset="0"/>
+                <a:cs typeface="Courier New" panose="02070309020205020404" pitchFamily="49" charset="0"/>
+              </a:rPr>
+              <a:t>/20.0.1</a:t>
+            </a:r>
+          </a:p>
+          <a:p>
+            <a:pPr lvl="1">
+              <a:lnSpc>
+                <a:spcPct val="150000"/>
+              </a:lnSpc>
+            </a:pPr>
+            <a:r>
+              <a:rPr lang="en-US" dirty="0" err="1">
+                <a:latin typeface="Courier New" panose="02070309020205020404" pitchFamily="49" charset="0"/>
+                <a:cs typeface="Courier New" panose="02070309020205020404" pitchFamily="49" charset="0"/>
+              </a:rPr>
+              <a:t>ddt</a:t>
+            </a:r>
+            <a:endParaRPr lang="en-US" dirty="0">
+              <a:latin typeface="Courier New" panose="02070309020205020404" pitchFamily="49" charset="0"/>
+              <a:cs typeface="Courier New" panose="02070309020205020404" pitchFamily="49" charset="0"/>
+            </a:endParaRPr>
           </a:p>
         </p:txBody>
       </p:sp>
     </p:spTree>
     <p:extLst>
       <p:ext uri="{BB962C8B-B14F-4D97-AF65-F5344CB8AC3E}">
-        <p14:creationId xmlns:p14="http://schemas.microsoft.com/office/powerpoint/2010/main" val="382755255"/>
-      </p:ext>
-    </p:extLst>
-  </p:cSld>
-  <p:clrMapOvr>
-    <a:masterClrMapping/>
-  </p:clrMapOvr>
-</p:sld>
-</file>
-
-<file path=ppt/slides/slide19.xml><?xml version="1.0" encoding="utf-8"?>
-<p:sld xmlns:a="http://schemas.openxmlformats.org/drawingml/2006/main" xmlns:r="http://schemas.openxmlformats.org/officeDocument/2006/relationships" xmlns:p="http://schemas.openxmlformats.org/presentationml/2006/main">
-  <p:cSld>
-    <p:spTree>
-      <p:nvGrpSpPr>
-        <p:cNvPr id="1" name=""/>
-        <p:cNvGrpSpPr/>
-        <p:nvPr/>
-      </p:nvGrpSpPr>
-      <p:grpSpPr>
-        <a:xfrm>
-          <a:off x="0" y="0"/>
-          <a:ext cx="0" cy="0"/>
-          <a:chOff x="0" y="0"/>
-          <a:chExt cx="0" cy="0"/>
-        </a:xfrm>
-      </p:grpSpPr>
-      <p:sp>
-        <p:nvSpPr>
-          <p:cNvPr id="5" name="Title 4">
-            <a:extLst>
-              <a:ext uri="{FF2B5EF4-FFF2-40B4-BE49-F238E27FC236}">
-                <a16:creationId xmlns:a16="http://schemas.microsoft.com/office/drawing/2014/main" id="{B36DB535-B2B8-DD49-916C-2B38FCB0595F}"/>
-              </a:ext>
-            </a:extLst>
-          </p:cNvPr>
-          <p:cNvSpPr>
-            <a:spLocks noGrp="1"/>
-          </p:cNvSpPr>
-          <p:nvPr>
-            <p:ph type="ctrTitle"/>
-          </p:nvPr>
-        </p:nvSpPr>
-        <p:spPr/>
-        <p:txBody>
-          <a:bodyPr/>
-          <a:lstStyle/>
-          <a:p>
-            <a:r>
-              <a:rPr lang="en-US" dirty="0"/>
-              <a:t>Have a great day!</a:t>
-            </a:r>
-          </a:p>
-        </p:txBody>
-      </p:sp>
-    </p:spTree>
-    <p:extLst>
-      <p:ext uri="{BB962C8B-B14F-4D97-AF65-F5344CB8AC3E}">
-        <p14:creationId xmlns:p14="http://schemas.microsoft.com/office/powerpoint/2010/main" val="3182097241"/>
+        <p14:creationId xmlns:p14="http://schemas.microsoft.com/office/powerpoint/2010/main" val="3956143696"/>
       </p:ext>
     </p:extLst>
   </p:cSld>
@@ -4610,7 +4567,23 @@
             </a:pPr>
             <a:r>
               <a:rPr lang="en-US" dirty="0"/>
-              <a:t>Python – PyCharm</a:t>
+              <a:t>Python – </a:t>
+            </a:r>
+            <a:r>
+              <a:rPr lang="en-US" dirty="0" err="1"/>
+              <a:t>VSCode</a:t>
+            </a:r>
+            <a:endParaRPr lang="en-US" dirty="0"/>
+          </a:p>
+          <a:p>
+            <a:pPr>
+              <a:lnSpc>
+                <a:spcPct val="150000"/>
+              </a:lnSpc>
+            </a:pPr>
+            <a:r>
+              <a:rPr lang="en-US" dirty="0"/>
+              <a:t>Debugging typical software errors </a:t>
             </a:r>
           </a:p>
           <a:p>
@@ -4621,7 +4594,7 @@
             </a:pPr>
             <a:r>
               <a:rPr lang="en-US" dirty="0"/>
-              <a:t>R – RStudio </a:t>
+              <a:t>Program crashes, Incorrect output</a:t>
             </a:r>
           </a:p>
           <a:p>
@@ -4632,7 +4605,7 @@
             </a:pPr>
             <a:r>
               <a:rPr lang="en-US" dirty="0"/>
-              <a:t>Debugging typical software errors </a:t>
+              <a:t>Profiling </a:t>
             </a:r>
           </a:p>
           <a:p>
@@ -4643,28 +4616,6 @@
             </a:pPr>
             <a:r>
               <a:rPr lang="en-US" dirty="0"/>
-              <a:t>Program crashes, Incorrect output</a:t>
-            </a:r>
-          </a:p>
-          <a:p>
-            <a:pPr>
-              <a:lnSpc>
-                <a:spcPct val="150000"/>
-              </a:lnSpc>
-            </a:pPr>
-            <a:r>
-              <a:rPr lang="en-US" dirty="0"/>
-              <a:t>Profiling </a:t>
-            </a:r>
-          </a:p>
-          <a:p>
-            <a:pPr lvl="1">
-              <a:lnSpc>
-                <a:spcPct val="150000"/>
-              </a:lnSpc>
-            </a:pPr>
-            <a:r>
-              <a:rPr lang="en-US" dirty="0"/>
               <a:t>Inefficient resource utilization (Time, Memory, CPU) </a:t>
             </a:r>
           </a:p>
@@ -4674,604 +4625,6 @@
     <p:extLst>
       <p:ext uri="{BB962C8B-B14F-4D97-AF65-F5344CB8AC3E}">
         <p14:creationId xmlns:p14="http://schemas.microsoft.com/office/powerpoint/2010/main" val="1628838780"/>
-      </p:ext>
-    </p:extLst>
-  </p:cSld>
-  <p:clrMapOvr>
-    <a:masterClrMapping/>
-  </p:clrMapOvr>
-</p:sld>
-</file>
-
-<file path=ppt/slides/slide20.xml><?xml version="1.0" encoding="utf-8"?>
-<p:sld xmlns:a="http://schemas.openxmlformats.org/drawingml/2006/main" xmlns:r="http://schemas.openxmlformats.org/officeDocument/2006/relationships" xmlns:p="http://schemas.openxmlformats.org/presentationml/2006/main" show="0">
-  <p:cSld>
-    <p:spTree>
-      <p:nvGrpSpPr>
-        <p:cNvPr id="1" name=""/>
-        <p:cNvGrpSpPr/>
-        <p:nvPr/>
-      </p:nvGrpSpPr>
-      <p:grpSpPr>
-        <a:xfrm>
-          <a:off x="0" y="0"/>
-          <a:ext cx="0" cy="0"/>
-          <a:chOff x="0" y="0"/>
-          <a:chExt cx="0" cy="0"/>
-        </a:xfrm>
-      </p:grpSpPr>
-      <p:sp>
-        <p:nvSpPr>
-          <p:cNvPr id="2" name="Title 1">
-            <a:extLst>
-              <a:ext uri="{FF2B5EF4-FFF2-40B4-BE49-F238E27FC236}">
-                <a16:creationId xmlns:a16="http://schemas.microsoft.com/office/drawing/2014/main" id="{8B1EB113-6772-47FD-B086-3D873CE8642B}"/>
-              </a:ext>
-            </a:extLst>
-          </p:cNvPr>
-          <p:cNvSpPr>
-            <a:spLocks noGrp="1"/>
-          </p:cNvSpPr>
-          <p:nvPr>
-            <p:ph type="title"/>
-          </p:nvPr>
-        </p:nvSpPr>
-        <p:spPr/>
-        <p:txBody>
-          <a:bodyPr/>
-          <a:lstStyle/>
-          <a:p>
-            <a:r>
-              <a:rPr lang="en-US" dirty="0"/>
-              <a:t>Handling C++</a:t>
-            </a:r>
-          </a:p>
-        </p:txBody>
-      </p:sp>
-      <p:sp>
-        <p:nvSpPr>
-          <p:cNvPr id="3" name="Content Placeholder 2">
-            <a:extLst>
-              <a:ext uri="{FF2B5EF4-FFF2-40B4-BE49-F238E27FC236}">
-                <a16:creationId xmlns:a16="http://schemas.microsoft.com/office/drawing/2014/main" id="{39D54DE9-CBB0-4FEC-AB4C-2C31E7FAC625}"/>
-              </a:ext>
-            </a:extLst>
-          </p:cNvPr>
-          <p:cNvSpPr>
-            <a:spLocks noGrp="1"/>
-          </p:cNvSpPr>
-          <p:nvPr>
-            <p:ph idx="1"/>
-          </p:nvPr>
-        </p:nvSpPr>
-        <p:spPr/>
-        <p:txBody>
-          <a:bodyPr>
-            <a:normAutofit fontScale="92500" lnSpcReduction="10000"/>
-          </a:bodyPr>
-          <a:lstStyle/>
-          <a:p>
-            <a:pPr>
-              <a:lnSpc>
-                <a:spcPct val="150000"/>
-              </a:lnSpc>
-            </a:pPr>
-            <a:r>
-              <a:rPr lang="en-US" dirty="0"/>
-              <a:t>C++ is somewhat different because it is compiled </a:t>
-            </a:r>
-          </a:p>
-          <a:p>
-            <a:pPr>
-              <a:lnSpc>
-                <a:spcPct val="150000"/>
-              </a:lnSpc>
-            </a:pPr>
-            <a:r>
-              <a:rPr lang="en-US" dirty="0"/>
-              <a:t>Some errors are found much earlier </a:t>
-            </a:r>
-          </a:p>
-          <a:p>
-            <a:pPr>
-              <a:lnSpc>
-                <a:spcPct val="150000"/>
-              </a:lnSpc>
-            </a:pPr>
-            <a:r>
-              <a:rPr lang="en-US" dirty="0"/>
-              <a:t>The build process needs to be setup</a:t>
-            </a:r>
-          </a:p>
-          <a:p>
-            <a:pPr lvl="1">
-              <a:lnSpc>
-                <a:spcPct val="150000"/>
-              </a:lnSpc>
-            </a:pPr>
-            <a:r>
-              <a:rPr lang="en-US" dirty="0"/>
-              <a:t>Compiler</a:t>
-            </a:r>
-          </a:p>
-          <a:p>
-            <a:pPr lvl="1">
-              <a:lnSpc>
-                <a:spcPct val="150000"/>
-              </a:lnSpc>
-            </a:pPr>
-            <a:r>
-              <a:rPr lang="en-US" dirty="0"/>
-              <a:t>Compiler options</a:t>
-            </a:r>
-          </a:p>
-          <a:p>
-            <a:pPr lvl="1">
-              <a:lnSpc>
-                <a:spcPct val="150000"/>
-              </a:lnSpc>
-            </a:pPr>
-            <a:r>
-              <a:rPr lang="en-US" dirty="0"/>
-              <a:t>Debug/Release builds</a:t>
-            </a:r>
-          </a:p>
-          <a:p>
-            <a:pPr>
-              <a:lnSpc>
-                <a:spcPct val="150000"/>
-              </a:lnSpc>
-            </a:pPr>
-            <a:r>
-              <a:rPr lang="en-US" dirty="0"/>
-              <a:t>Errors messages can be less obvious </a:t>
-            </a:r>
-          </a:p>
-        </p:txBody>
-      </p:sp>
-    </p:spTree>
-    <p:extLst>
-      <p:ext uri="{BB962C8B-B14F-4D97-AF65-F5344CB8AC3E}">
-        <p14:creationId xmlns:p14="http://schemas.microsoft.com/office/powerpoint/2010/main" val="237925523"/>
-      </p:ext>
-    </p:extLst>
-  </p:cSld>
-  <p:clrMapOvr>
-    <a:masterClrMapping/>
-  </p:clrMapOvr>
-</p:sld>
-</file>
-
-<file path=ppt/slides/slide21.xml><?xml version="1.0" encoding="utf-8"?>
-<p:sld xmlns:a="http://schemas.openxmlformats.org/drawingml/2006/main" xmlns:r="http://schemas.openxmlformats.org/officeDocument/2006/relationships" xmlns:p="http://schemas.openxmlformats.org/presentationml/2006/main" show="0">
-  <p:cSld>
-    <p:spTree>
-      <p:nvGrpSpPr>
-        <p:cNvPr id="1" name=""/>
-        <p:cNvGrpSpPr/>
-        <p:nvPr/>
-      </p:nvGrpSpPr>
-      <p:grpSpPr>
-        <a:xfrm>
-          <a:off x="0" y="0"/>
-          <a:ext cx="0" cy="0"/>
-          <a:chOff x="0" y="0"/>
-          <a:chExt cx="0" cy="0"/>
-        </a:xfrm>
-      </p:grpSpPr>
-      <p:sp>
-        <p:nvSpPr>
-          <p:cNvPr id="2" name="Title 1">
-            <a:extLst>
-              <a:ext uri="{FF2B5EF4-FFF2-40B4-BE49-F238E27FC236}">
-                <a16:creationId xmlns:a16="http://schemas.microsoft.com/office/drawing/2014/main" id="{E12BE167-F6C9-4FD8-AE90-A43FAAA42A07}"/>
-              </a:ext>
-            </a:extLst>
-          </p:cNvPr>
-          <p:cNvSpPr>
-            <a:spLocks noGrp="1"/>
-          </p:cNvSpPr>
-          <p:nvPr>
-            <p:ph type="title"/>
-          </p:nvPr>
-        </p:nvSpPr>
-        <p:spPr/>
-        <p:txBody>
-          <a:bodyPr/>
-          <a:lstStyle/>
-          <a:p>
-            <a:r>
-              <a:rPr lang="en-US" dirty="0"/>
-              <a:t>Exercise 4 : C++ Setup</a:t>
-            </a:r>
-          </a:p>
-        </p:txBody>
-      </p:sp>
-      <p:sp>
-        <p:nvSpPr>
-          <p:cNvPr id="3" name="Content Placeholder 2">
-            <a:extLst>
-              <a:ext uri="{FF2B5EF4-FFF2-40B4-BE49-F238E27FC236}">
-                <a16:creationId xmlns:a16="http://schemas.microsoft.com/office/drawing/2014/main" id="{6D93E6B7-65B4-4005-895B-4CD959210943}"/>
-              </a:ext>
-            </a:extLst>
-          </p:cNvPr>
-          <p:cNvSpPr>
-            <a:spLocks noGrp="1"/>
-          </p:cNvSpPr>
-          <p:nvPr>
-            <p:ph idx="1"/>
-          </p:nvPr>
-        </p:nvSpPr>
-        <p:spPr>
-          <a:xfrm>
-            <a:off x="211015" y="1825625"/>
-            <a:ext cx="8745415" cy="4351338"/>
-          </a:xfrm>
-        </p:spPr>
-        <p:txBody>
-          <a:bodyPr>
-            <a:normAutofit/>
-          </a:bodyPr>
-          <a:lstStyle/>
-          <a:p>
-            <a:pPr>
-              <a:lnSpc>
-                <a:spcPct val="150000"/>
-              </a:lnSpc>
-            </a:pPr>
-            <a:r>
-              <a:rPr lang="en-US" dirty="0"/>
-              <a:t>Log onto Adroit </a:t>
-            </a:r>
-          </a:p>
-          <a:p>
-            <a:pPr lvl="1">
-              <a:lnSpc>
-                <a:spcPct val="150000"/>
-              </a:lnSpc>
-            </a:pPr>
-            <a:r>
-              <a:rPr lang="en-US" dirty="0" err="1">
-                <a:latin typeface="Courier New" panose="02070309020205020404" pitchFamily="49" charset="0"/>
-                <a:cs typeface="Courier New" panose="02070309020205020404" pitchFamily="49" charset="0"/>
-              </a:rPr>
-              <a:t>ssh</a:t>
-            </a:r>
-            <a:r>
-              <a:rPr lang="en-US" dirty="0">
-                <a:latin typeface="Courier New" panose="02070309020205020404" pitchFamily="49" charset="0"/>
-                <a:cs typeface="Courier New" panose="02070309020205020404" pitchFamily="49" charset="0"/>
-              </a:rPr>
-              <a:t> -X adroit.princeton.edu</a:t>
-            </a:r>
-          </a:p>
-          <a:p>
-            <a:pPr>
-              <a:lnSpc>
-                <a:spcPct val="150000"/>
-              </a:lnSpc>
-            </a:pPr>
-            <a:r>
-              <a:rPr lang="en-US" dirty="0"/>
-              <a:t>Download the C++ code</a:t>
-            </a:r>
-          </a:p>
-          <a:p>
-            <a:pPr lvl="1">
-              <a:lnSpc>
-                <a:spcPct val="150000"/>
-              </a:lnSpc>
-            </a:pPr>
-            <a:r>
-              <a:rPr lang="pt-BR" sz="1800" dirty="0">
-                <a:latin typeface="Courier New" panose="02070309020205020404" pitchFamily="49" charset="0"/>
-                <a:cs typeface="Courier New" panose="02070309020205020404" pitchFamily="49" charset="0"/>
-              </a:rPr>
-              <a:t>curl -L -o cpp_debug.zip https://tinyurl.com/y3k73w6y</a:t>
-            </a:r>
-            <a:endParaRPr lang="en-US" sz="1800" dirty="0">
-              <a:latin typeface="Courier New" panose="02070309020205020404" pitchFamily="49" charset="0"/>
-              <a:cs typeface="Courier New" panose="02070309020205020404" pitchFamily="49" charset="0"/>
-            </a:endParaRPr>
-          </a:p>
-          <a:p>
-            <a:pPr lvl="1">
-              <a:lnSpc>
-                <a:spcPct val="150000"/>
-              </a:lnSpc>
-            </a:pPr>
-            <a:r>
-              <a:rPr lang="en-US" dirty="0">
-                <a:latin typeface="Courier New" panose="02070309020205020404" pitchFamily="49" charset="0"/>
-                <a:cs typeface="Courier New" panose="02070309020205020404" pitchFamily="49" charset="0"/>
-              </a:rPr>
-              <a:t>unzip </a:t>
-            </a:r>
-            <a:r>
-              <a:rPr lang="en-US" dirty="0" err="1">
-                <a:latin typeface="Courier New" panose="02070309020205020404" pitchFamily="49" charset="0"/>
-                <a:cs typeface="Courier New" panose="02070309020205020404" pitchFamily="49" charset="0"/>
-              </a:rPr>
-              <a:t>cpp</a:t>
-            </a:r>
-            <a:r>
-              <a:rPr lang="en-US" dirty="0">
-                <a:latin typeface="Courier New" panose="02070309020205020404" pitchFamily="49" charset="0"/>
-                <a:cs typeface="Courier New" panose="02070309020205020404" pitchFamily="49" charset="0"/>
-              </a:rPr>
-              <a:t>_</a:t>
-            </a:r>
-            <a:r>
-              <a:rPr lang="pt-BR" dirty="0">
-                <a:latin typeface="Courier New" panose="02070309020205020404" pitchFamily="49" charset="0"/>
-                <a:cs typeface="Courier New" panose="02070309020205020404" pitchFamily="49" charset="0"/>
-              </a:rPr>
-              <a:t>debug</a:t>
-            </a:r>
-            <a:r>
-              <a:rPr lang="en-US" dirty="0">
-                <a:latin typeface="Courier New" panose="02070309020205020404" pitchFamily="49" charset="0"/>
-                <a:cs typeface="Courier New" panose="02070309020205020404" pitchFamily="49" charset="0"/>
-              </a:rPr>
-              <a:t>.zip </a:t>
-            </a:r>
-          </a:p>
-          <a:p>
-            <a:pPr lvl="1">
-              <a:lnSpc>
-                <a:spcPct val="150000"/>
-              </a:lnSpc>
-            </a:pPr>
-            <a:r>
-              <a:rPr lang="en-US" dirty="0">
-                <a:latin typeface="Courier New" panose="02070309020205020404" pitchFamily="49" charset="0"/>
-                <a:cs typeface="Courier New" panose="02070309020205020404" pitchFamily="49" charset="0"/>
-              </a:rPr>
-              <a:t>cd </a:t>
-            </a:r>
-            <a:r>
-              <a:rPr lang="en-US" dirty="0" err="1">
-                <a:latin typeface="Courier New" panose="02070309020205020404" pitchFamily="49" charset="0"/>
-                <a:cs typeface="Courier New" panose="02070309020205020404" pitchFamily="49" charset="0"/>
-              </a:rPr>
-              <a:t>cpp</a:t>
-            </a:r>
-            <a:r>
-              <a:rPr lang="en-US" dirty="0">
-                <a:latin typeface="Courier New" panose="02070309020205020404" pitchFamily="49" charset="0"/>
-                <a:cs typeface="Courier New" panose="02070309020205020404" pitchFamily="49" charset="0"/>
-              </a:rPr>
-              <a:t>_</a:t>
-            </a:r>
-            <a:r>
-              <a:rPr lang="pt-BR" dirty="0">
-                <a:latin typeface="Courier New" panose="02070309020205020404" pitchFamily="49" charset="0"/>
-                <a:cs typeface="Courier New" panose="02070309020205020404" pitchFamily="49" charset="0"/>
-              </a:rPr>
-              <a:t>debug</a:t>
-            </a:r>
-            <a:endParaRPr lang="en-US" dirty="0">
-              <a:latin typeface="Courier New" panose="02070309020205020404" pitchFamily="49" charset="0"/>
-              <a:cs typeface="Courier New" panose="02070309020205020404" pitchFamily="49" charset="0"/>
-            </a:endParaRPr>
-          </a:p>
-        </p:txBody>
-      </p:sp>
-    </p:spTree>
-    <p:extLst>
-      <p:ext uri="{BB962C8B-B14F-4D97-AF65-F5344CB8AC3E}">
-        <p14:creationId xmlns:p14="http://schemas.microsoft.com/office/powerpoint/2010/main" val="1010424374"/>
-      </p:ext>
-    </p:extLst>
-  </p:cSld>
-  <p:clrMapOvr>
-    <a:masterClrMapping/>
-  </p:clrMapOvr>
-</p:sld>
-</file>
-
-<file path=ppt/slides/slide22.xml><?xml version="1.0" encoding="utf-8"?>
-<p:sld xmlns:a="http://schemas.openxmlformats.org/drawingml/2006/main" xmlns:r="http://schemas.openxmlformats.org/officeDocument/2006/relationships" xmlns:p="http://schemas.openxmlformats.org/presentationml/2006/main" show="0">
-  <p:cSld>
-    <p:spTree>
-      <p:nvGrpSpPr>
-        <p:cNvPr id="1" name=""/>
-        <p:cNvGrpSpPr/>
-        <p:nvPr/>
-      </p:nvGrpSpPr>
-      <p:grpSpPr>
-        <a:xfrm>
-          <a:off x="0" y="0"/>
-          <a:ext cx="0" cy="0"/>
-          <a:chOff x="0" y="0"/>
-          <a:chExt cx="0" cy="0"/>
-        </a:xfrm>
-      </p:grpSpPr>
-      <p:sp>
-        <p:nvSpPr>
-          <p:cNvPr id="2" name="Title 1">
-            <a:extLst>
-              <a:ext uri="{FF2B5EF4-FFF2-40B4-BE49-F238E27FC236}">
-                <a16:creationId xmlns:a16="http://schemas.microsoft.com/office/drawing/2014/main" id="{0A2DA531-92ED-4623-A4B8-90CE8F756834}"/>
-              </a:ext>
-            </a:extLst>
-          </p:cNvPr>
-          <p:cNvSpPr>
-            <a:spLocks noGrp="1"/>
-          </p:cNvSpPr>
-          <p:nvPr>
-            <p:ph type="title"/>
-          </p:nvPr>
-        </p:nvSpPr>
-        <p:spPr/>
-        <p:txBody>
-          <a:bodyPr/>
-          <a:lstStyle/>
-          <a:p>
-            <a:r>
-              <a:rPr lang="en-US" dirty="0"/>
-              <a:t>Exercise 4 : C++ Compile and Run </a:t>
-            </a:r>
-          </a:p>
-        </p:txBody>
-      </p:sp>
-      <p:sp>
-        <p:nvSpPr>
-          <p:cNvPr id="3" name="Content Placeholder 2">
-            <a:extLst>
-              <a:ext uri="{FF2B5EF4-FFF2-40B4-BE49-F238E27FC236}">
-                <a16:creationId xmlns:a16="http://schemas.microsoft.com/office/drawing/2014/main" id="{D1BF4B0F-0AD3-470A-B163-9EDCD95D5A97}"/>
-              </a:ext>
-            </a:extLst>
-          </p:cNvPr>
-          <p:cNvSpPr>
-            <a:spLocks noGrp="1"/>
-          </p:cNvSpPr>
-          <p:nvPr>
-            <p:ph idx="1"/>
-          </p:nvPr>
-        </p:nvSpPr>
-        <p:spPr/>
-        <p:txBody>
-          <a:bodyPr>
-            <a:normAutofit fontScale="92500" lnSpcReduction="20000"/>
-          </a:bodyPr>
-          <a:lstStyle/>
-          <a:p>
-            <a:pPr>
-              <a:lnSpc>
-                <a:spcPct val="150000"/>
-              </a:lnSpc>
-            </a:pPr>
-            <a:r>
-              <a:rPr lang="en-US" dirty="0"/>
-              <a:t>Compile the code</a:t>
-            </a:r>
-          </a:p>
-          <a:p>
-            <a:pPr lvl="1">
-              <a:lnSpc>
-                <a:spcPct val="150000"/>
-              </a:lnSpc>
-            </a:pPr>
-            <a:r>
-              <a:rPr lang="pt-BR" dirty="0">
-                <a:latin typeface="Courier New" panose="02070309020205020404" pitchFamily="49" charset="0"/>
-                <a:cs typeface="Courier New" panose="02070309020205020404" pitchFamily="49" charset="0"/>
-              </a:rPr>
-              <a:t>g++ -g -O0 -o serial_cpp serial.cpp</a:t>
-            </a:r>
-          </a:p>
-          <a:p>
-            <a:pPr>
-              <a:lnSpc>
-                <a:spcPct val="150000"/>
-              </a:lnSpc>
-            </a:pPr>
-            <a:r>
-              <a:rPr lang="pt-BR" dirty="0"/>
-              <a:t>Request a task node on Adroit</a:t>
-            </a:r>
-          </a:p>
-          <a:p>
-            <a:pPr lvl="1">
-              <a:lnSpc>
-                <a:spcPct val="150000"/>
-              </a:lnSpc>
-            </a:pPr>
-            <a:r>
-              <a:rPr lang="en-US" dirty="0" err="1">
-                <a:latin typeface="Courier New" panose="02070309020205020404" pitchFamily="49" charset="0"/>
-                <a:cs typeface="Courier New" panose="02070309020205020404" pitchFamily="49" charset="0"/>
-              </a:rPr>
-              <a:t>salloc</a:t>
-            </a:r>
-            <a:r>
-              <a:rPr lang="en-US" dirty="0">
-                <a:latin typeface="Courier New" panose="02070309020205020404" pitchFamily="49" charset="0"/>
-                <a:cs typeface="Courier New" panose="02070309020205020404" pitchFamily="49" charset="0"/>
-              </a:rPr>
-              <a:t> --nodes=1 --</a:t>
-            </a:r>
-            <a:r>
-              <a:rPr lang="en-US" dirty="0" err="1">
-                <a:latin typeface="Courier New" panose="02070309020205020404" pitchFamily="49" charset="0"/>
-                <a:cs typeface="Courier New" panose="02070309020205020404" pitchFamily="49" charset="0"/>
-              </a:rPr>
-              <a:t>ntasks</a:t>
-            </a:r>
-            <a:r>
-              <a:rPr lang="en-US" dirty="0">
-                <a:latin typeface="Courier New" panose="02070309020205020404" pitchFamily="49" charset="0"/>
-                <a:cs typeface="Courier New" panose="02070309020205020404" pitchFamily="49" charset="0"/>
-              </a:rPr>
-              <a:t>=1 --time=05:00 --x11</a:t>
-            </a:r>
-          </a:p>
-          <a:p>
-            <a:pPr>
-              <a:lnSpc>
-                <a:spcPct val="150000"/>
-              </a:lnSpc>
-            </a:pPr>
-            <a:r>
-              <a:rPr lang="en-US" dirty="0"/>
-              <a:t>Load the Arm DDT debugger </a:t>
-            </a:r>
-          </a:p>
-          <a:p>
-            <a:pPr lvl="1">
-              <a:lnSpc>
-                <a:spcPct val="150000"/>
-              </a:lnSpc>
-            </a:pPr>
-            <a:r>
-              <a:rPr lang="en-US" dirty="0">
-                <a:latin typeface="Courier New" panose="02070309020205020404" pitchFamily="49" charset="0"/>
-                <a:cs typeface="Courier New" panose="02070309020205020404" pitchFamily="49" charset="0"/>
-              </a:rPr>
-              <a:t>module load </a:t>
-            </a:r>
-            <a:r>
-              <a:rPr lang="en-US" dirty="0" err="1">
-                <a:latin typeface="Courier New" panose="02070309020205020404" pitchFamily="49" charset="0"/>
-                <a:cs typeface="Courier New" panose="02070309020205020404" pitchFamily="49" charset="0"/>
-              </a:rPr>
-              <a:t>ddt</a:t>
-            </a:r>
-            <a:r>
-              <a:rPr lang="en-US" dirty="0">
-                <a:latin typeface="Courier New" panose="02070309020205020404" pitchFamily="49" charset="0"/>
-                <a:cs typeface="Courier New" panose="02070309020205020404" pitchFamily="49" charset="0"/>
-              </a:rPr>
-              <a:t>/20.0.1</a:t>
-            </a:r>
-          </a:p>
-          <a:p>
-            <a:pPr lvl="1">
-              <a:lnSpc>
-                <a:spcPct val="150000"/>
-              </a:lnSpc>
-            </a:pPr>
-            <a:r>
-              <a:rPr lang="en-US" dirty="0" err="1">
-                <a:latin typeface="Courier New" panose="02070309020205020404" pitchFamily="49" charset="0"/>
-                <a:cs typeface="Courier New" panose="02070309020205020404" pitchFamily="49" charset="0"/>
-              </a:rPr>
-              <a:t>ddt</a:t>
-            </a:r>
-            <a:endParaRPr lang="en-US" dirty="0">
-              <a:latin typeface="Courier New" panose="02070309020205020404" pitchFamily="49" charset="0"/>
-              <a:cs typeface="Courier New" panose="02070309020205020404" pitchFamily="49" charset="0"/>
-            </a:endParaRPr>
-          </a:p>
-        </p:txBody>
-      </p:sp>
-    </p:spTree>
-    <p:extLst>
-      <p:ext uri="{BB962C8B-B14F-4D97-AF65-F5344CB8AC3E}">
-        <p14:creationId xmlns:p14="http://schemas.microsoft.com/office/powerpoint/2010/main" val="3956143696"/>
       </p:ext>
     </p:extLst>
   </p:cSld>
@@ -5680,11 +5033,11 @@
             <a:pPr lvl="1"/>
             <a:r>
               <a:rPr lang="en-US" dirty="0" err="1"/>
-              <a:t>pdbpp</a:t>
-            </a:r>
-            <a:r>
-              <a:rPr lang="en-US" dirty="0"/>
-              <a:t> is a more user-friendly version</a:t>
+              <a:t>pdb</a:t>
+            </a:r>
+            <a:r>
+              <a:rPr lang="en-US" dirty="0"/>
+              <a:t>++ is a more user-friendly version</a:t>
             </a:r>
           </a:p>
           <a:p>
@@ -6150,7 +5503,7 @@
           <p:cNvPr id="2" name="Title 1">
             <a:extLst>
               <a:ext uri="{FF2B5EF4-FFF2-40B4-BE49-F238E27FC236}">
-                <a16:creationId xmlns:a16="http://schemas.microsoft.com/office/drawing/2014/main" id="{A379E64E-A465-4CB2-89C3-BFA874E0AF25}"/>
+                <a16:creationId xmlns:a16="http://schemas.microsoft.com/office/drawing/2014/main" id="{2A487E68-2AB4-4828-8937-3390A9A6FDD5}"/>
               </a:ext>
             </a:extLst>
           </p:cNvPr>
@@ -6168,7 +5521,7 @@
           <a:p>
             <a:r>
               <a:rPr lang="en-US" dirty="0"/>
-              <a:t>Exercise 1: PyCharm Setup</a:t>
+              <a:t>Exercise 2 : Fix The Tests!</a:t>
             </a:r>
           </a:p>
         </p:txBody>
@@ -6178,7 +5531,7 @@
           <p:cNvPr id="3" name="Content Placeholder 2">
             <a:extLst>
               <a:ext uri="{FF2B5EF4-FFF2-40B4-BE49-F238E27FC236}">
-                <a16:creationId xmlns:a16="http://schemas.microsoft.com/office/drawing/2014/main" id="{7A72F666-C529-471D-BCC3-7CE9B9DE1FB3}"/>
+                <a16:creationId xmlns:a16="http://schemas.microsoft.com/office/drawing/2014/main" id="{72CEC002-3008-4DC4-A0AF-E385D1339B6B}"/>
               </a:ext>
             </a:extLst>
           </p:cNvPr>
@@ -6191,103 +5544,67 @@
         </p:nvSpPr>
         <p:spPr>
           <a:xfrm>
-            <a:off x="628650" y="1535722"/>
-            <a:ext cx="8140212" cy="4957151"/>
+            <a:off x="628650" y="2728302"/>
+            <a:ext cx="7886700" cy="2183668"/>
           </a:xfrm>
         </p:spPr>
         <p:txBody>
-          <a:bodyPr>
-            <a:normAutofit/>
-          </a:bodyPr>
-          <a:lstStyle/>
-          <a:p>
-            <a:pPr>
-              <a:lnSpc>
-                <a:spcPct val="150000"/>
-              </a:lnSpc>
-            </a:pPr>
-            <a:r>
-              <a:rPr lang="en-US" dirty="0"/>
-              <a:t>Start Anaconda Navigator and launch PyCharm</a:t>
-            </a:r>
-          </a:p>
-          <a:p>
-            <a:pPr lvl="1">
-              <a:lnSpc>
-                <a:spcPct val="150000"/>
-              </a:lnSpc>
-            </a:pPr>
-            <a:r>
-              <a:rPr lang="en-US" dirty="0"/>
-              <a:t>Go to File &gt; New Project</a:t>
-            </a:r>
-          </a:p>
-          <a:p>
-            <a:pPr lvl="1">
-              <a:lnSpc>
-                <a:spcPct val="150000"/>
-              </a:lnSpc>
-            </a:pPr>
-            <a:r>
-              <a:rPr lang="en-US" dirty="0"/>
-              <a:t>Navigate to the “</a:t>
-            </a:r>
-            <a:r>
-              <a:rPr lang="en-US" dirty="0" err="1"/>
-              <a:t>python_debug</a:t>
-            </a:r>
-            <a:r>
-              <a:rPr lang="en-US" dirty="0"/>
-              <a:t>” project directory</a:t>
-            </a:r>
-          </a:p>
-          <a:p>
-            <a:pPr lvl="1">
-              <a:lnSpc>
-                <a:spcPct val="150000"/>
-              </a:lnSpc>
-            </a:pPr>
-            <a:r>
-              <a:rPr lang="en-US" b="1" dirty="0"/>
-              <a:t>Create project using existing files</a:t>
-            </a:r>
-          </a:p>
-          <a:p>
-            <a:pPr>
-              <a:lnSpc>
-                <a:spcPct val="150000"/>
-              </a:lnSpc>
-            </a:pPr>
-            <a:r>
-              <a:rPr lang="en-US" dirty="0"/>
-              <a:t>Understand project structure</a:t>
-            </a:r>
-          </a:p>
-          <a:p>
-            <a:pPr lvl="1">
-              <a:lnSpc>
-                <a:spcPct val="150000"/>
-              </a:lnSpc>
-            </a:pPr>
-            <a:r>
-              <a:rPr lang="en-US" dirty="0"/>
-              <a:t>Set source root as the “</a:t>
-            </a:r>
-            <a:r>
-              <a:rPr lang="en-US" dirty="0" err="1"/>
-              <a:t>src</a:t>
-            </a:r>
-            <a:r>
-              <a:rPr lang="en-US" dirty="0"/>
-              <a:t>” directory (right click option)</a:t>
-            </a:r>
+          <a:bodyPr/>
+          <a:lstStyle/>
+          <a:p>
+            <a:r>
+              <a:rPr lang="en-US" dirty="0"/>
+              <a:t>Fix the failing test cases…</a:t>
+            </a:r>
+          </a:p>
+          <a:p>
+            <a:r>
+              <a:rPr lang="en-US" dirty="0"/>
+              <a:t>Useful links</a:t>
+            </a:r>
+          </a:p>
+          <a:p>
+            <a:pPr lvl="1"/>
+            <a:r>
+              <a:rPr lang="en-US" dirty="0">
+                <a:hlinkClick r:id="rId2"/>
+              </a:rPr>
+              <a:t>https://byjus.com/maths/area-of-shapes</a:t>
+            </a:r>
+            <a:endParaRPr lang="en-US" dirty="0"/>
+          </a:p>
+          <a:p>
+            <a:pPr lvl="1"/>
+            <a:r>
+              <a:rPr lang="en-US" dirty="0">
+                <a:hlinkClick r:id="rId3"/>
+              </a:rPr>
+              <a:t>https://byjus.com/volume-formulas</a:t>
+            </a:r>
+            <a:endParaRPr lang="en-US" dirty="0"/>
+          </a:p>
+          <a:p>
+            <a:pPr lvl="1"/>
+            <a:r>
+              <a:rPr lang="en-US" dirty="0">
+                <a:hlinkClick r:id="rId4"/>
+              </a:rPr>
+              <a:t>https://byjus.com/surface-area-formulas</a:t>
+            </a:r>
+            <a:r>
+              <a:rPr lang="en-US" dirty="0"/>
+              <a:t> </a:t>
+            </a:r>
+          </a:p>
+          <a:p>
+            <a:endParaRPr lang="en-US" dirty="0"/>
           </a:p>
         </p:txBody>
       </p:sp>
     </p:spTree>
     <p:extLst>
       <p:ext uri="{BB962C8B-B14F-4D97-AF65-F5344CB8AC3E}">
-        <p14:creationId xmlns:p14="http://schemas.microsoft.com/office/powerpoint/2010/main" val="3287837250"/>
+        <p14:creationId xmlns:p14="http://schemas.microsoft.com/office/powerpoint/2010/main" val="1044877323"/>
       </p:ext>
     </p:extLst>
   </p:cSld>
@@ -6319,7 +5636,7 @@
           <p:cNvPr id="2" name="Title 1">
             <a:extLst>
               <a:ext uri="{FF2B5EF4-FFF2-40B4-BE49-F238E27FC236}">
-                <a16:creationId xmlns:a16="http://schemas.microsoft.com/office/drawing/2014/main" id="{2A487E68-2AB4-4828-8937-3390A9A6FDD5}"/>
+                <a16:creationId xmlns:a16="http://schemas.microsoft.com/office/drawing/2014/main" id="{5C298627-CFD5-A84F-8C30-6F138E6AD524}"/>
               </a:ext>
             </a:extLst>
           </p:cNvPr>
@@ -6337,7 +5654,7 @@
           <a:p>
             <a:r>
               <a:rPr lang="en-US" dirty="0"/>
-              <a:t>Exercise 2 : Fix The Tests!</a:t>
+              <a:t>Conditional Breakpoints</a:t>
             </a:r>
           </a:p>
         </p:txBody>
@@ -6347,7 +5664,7 @@
           <p:cNvPr id="3" name="Content Placeholder 2">
             <a:extLst>
               <a:ext uri="{FF2B5EF4-FFF2-40B4-BE49-F238E27FC236}">
-                <a16:creationId xmlns:a16="http://schemas.microsoft.com/office/drawing/2014/main" id="{72CEC002-3008-4DC4-A0AF-E385D1339B6B}"/>
+                <a16:creationId xmlns:a16="http://schemas.microsoft.com/office/drawing/2014/main" id="{2BFD590D-9D84-284D-BE51-CE87B2A0EF92}"/>
               </a:ext>
             </a:extLst>
           </p:cNvPr>
@@ -6358,69 +5675,79 @@
             <p:ph idx="1"/>
           </p:nvPr>
         </p:nvSpPr>
-        <p:spPr>
-          <a:xfrm>
-            <a:off x="628650" y="2728302"/>
-            <a:ext cx="7886700" cy="2183668"/>
-          </a:xfrm>
-        </p:spPr>
-        <p:txBody>
-          <a:bodyPr/>
-          <a:lstStyle/>
-          <a:p>
-            <a:r>
-              <a:rPr lang="en-US" dirty="0"/>
-              <a:t>Fix the failing test cases…</a:t>
-            </a:r>
-          </a:p>
-          <a:p>
-            <a:r>
-              <a:rPr lang="en-US" dirty="0"/>
-              <a:t>Useful links</a:t>
-            </a:r>
-          </a:p>
-          <a:p>
-            <a:pPr lvl="1"/>
-            <a:r>
-              <a:rPr lang="en-US" dirty="0">
-                <a:hlinkClick r:id="rId2"/>
-              </a:rPr>
-              <a:t>https://byjus.com/maths/area-of-shapes</a:t>
-            </a:r>
-            <a:endParaRPr lang="en-US" dirty="0"/>
-          </a:p>
-          <a:p>
-            <a:pPr lvl="1"/>
-            <a:r>
-              <a:rPr lang="en-US" dirty="0">
-                <a:hlinkClick r:id="rId3"/>
-              </a:rPr>
-              <a:t>https://byjus.com/volume-formulas</a:t>
-            </a:r>
-            <a:endParaRPr lang="en-US" dirty="0"/>
-          </a:p>
-          <a:p>
-            <a:pPr lvl="1"/>
-            <a:r>
-              <a:rPr lang="en-US" dirty="0">
-                <a:hlinkClick r:id="rId4"/>
-              </a:rPr>
-              <a:t>https://byjus.com/surface-area-formulas</a:t>
-            </a:r>
-            <a:r>
-              <a:rPr lang="en-US" dirty="0"/>
-              <a:t> </a:t>
-            </a:r>
-          </a:p>
-          <a:p>
-            <a:endParaRPr lang="en-US" dirty="0"/>
+        <p:spPr/>
+        <p:txBody>
+          <a:bodyPr/>
+          <a:lstStyle/>
+          <a:p>
+            <a:pPr>
+              <a:lnSpc>
+                <a:spcPct val="200000"/>
+              </a:lnSpc>
+            </a:pPr>
+            <a:r>
+              <a:rPr lang="en-US" dirty="0"/>
+              <a:t>Sometimes breakpoints need to be conditional</a:t>
+            </a:r>
+          </a:p>
+          <a:p>
+            <a:pPr lvl="1">
+              <a:lnSpc>
+                <a:spcPct val="200000"/>
+              </a:lnSpc>
+            </a:pPr>
+            <a:r>
+              <a:rPr lang="en-US" dirty="0"/>
+              <a:t>Useful when breaking at a certain iteration</a:t>
+            </a:r>
+          </a:p>
+          <a:p>
+            <a:pPr lvl="1">
+              <a:lnSpc>
+                <a:spcPct val="200000"/>
+              </a:lnSpc>
+            </a:pPr>
+            <a:r>
+              <a:rPr lang="en-US" dirty="0"/>
+              <a:t>Breaking on a certain call of the function </a:t>
+            </a:r>
+          </a:p>
+          <a:p>
+            <a:pPr>
+              <a:lnSpc>
+                <a:spcPct val="200000"/>
+              </a:lnSpc>
+            </a:pPr>
+            <a:r>
+              <a:rPr lang="en-US" dirty="0"/>
+              <a:t>Run the “</a:t>
+            </a:r>
+            <a:r>
+              <a:rPr lang="en-US" dirty="0" err="1"/>
+              <a:t>triangle_area_many.py</a:t>
+            </a:r>
+            <a:r>
+              <a:rPr lang="en-US" dirty="0"/>
+              <a:t>” example</a:t>
+            </a:r>
+          </a:p>
+          <a:p>
+            <a:pPr lvl="1">
+              <a:lnSpc>
+                <a:spcPct val="200000"/>
+              </a:lnSpc>
+            </a:pPr>
+            <a:r>
+              <a:rPr lang="en-US" dirty="0"/>
+              <a:t>Figure out which of the 10000 triangles is failing!</a:t>
+            </a:r>
           </a:p>
         </p:txBody>
       </p:sp>
     </p:spTree>
     <p:extLst>
       <p:ext uri="{BB962C8B-B14F-4D97-AF65-F5344CB8AC3E}">
-        <p14:creationId xmlns:p14="http://schemas.microsoft.com/office/powerpoint/2010/main" val="1044877323"/>
+        <p14:creationId xmlns:p14="http://schemas.microsoft.com/office/powerpoint/2010/main" val="3614469301"/>
       </p:ext>
     </p:extLst>
   </p:cSld>

</xml_diff>